<commit_message>
Update PPTX slide decks to reflect correct Personas and statistical outcomes
</commit_message>
<xml_diff>
--- a/docs/Week3_Experiment_Design_Summary.pptx
+++ b/docs/Week3_Experiment_Design_Summary.pptx
@@ -5301,33 +5301,11 @@
           </a:bodyPr>
           <a:lstStyle/>
           <a:p>
-            <a:pPr>
-              <a:spcAft>
-                <a:spcPts val="400"/>
-              </a:spcAft>
-              <a:defRPr sz="1400">
-                <a:solidFill>
-                  <a:srgbClr val="FFFFFF"/>
-                </a:solidFill>
-                <a:latin typeface="Segoe UI"/>
-              </a:defRPr>
-            </a:pPr>
-            <a:r>
-              <a:t>• Chỉ chọn nhóm Nhạy cảm giá (Persuadables): Urban Credit Card và Suburban Occasionals.</a:t>
-            </a:r>
-          </a:p>
-          <a:p>
-            <a:pPr>
-              <a:spcAft>
-                <a:spcPts val="400"/>
-              </a:spcAft>
-              <a:defRPr sz="1400">
-                <a:solidFill>
-                  <a:srgbClr val="FFFFFF"/>
-                </a:solidFill>
-                <a:latin typeface="Segoe UI"/>
-              </a:defRPr>
-            </a:pPr>
+            <a:r>
+              <a:t>• Chỉ chọn nhóm Nhạy cảm giá (Persuadables): Suburban Card.</a:t>
+            </a:r>
+          </a:p>
+          <a:p>
             <a:r>
               <a:t>• Đã ngủ đông từ 5-14 ngày.</a:t>
             </a:r>
@@ -5478,33 +5456,11 @@
           </a:bodyPr>
           <a:lstStyle/>
           <a:p>
-            <a:pPr>
-              <a:spcAft>
-                <a:spcPts val="400"/>
-              </a:spcAft>
-              <a:defRPr sz="1400">
-                <a:solidFill>
-                  <a:srgbClr val="FFFFFF"/>
-                </a:solidFill>
-                <a:latin typeface="Segoe UI"/>
-              </a:defRPr>
-            </a:pPr>
-            <a:r>
-              <a:t>• Khách đi sân bay (Kháng sale) và Khách đi làm giờ cao điểm (Bắt buộc phải đi).</a:t>
-            </a:r>
-          </a:p>
-          <a:p>
-            <a:pPr>
-              <a:spcAft>
-                <a:spcPts val="400"/>
-              </a:spcAft>
-              <a:defRPr sz="1400">
-                <a:solidFill>
-                  <a:srgbClr val="FFFFFF"/>
-                </a:solidFill>
-                <a:latin typeface="Segoe UI"/>
-              </a:defRPr>
-            </a:pPr>
+            <a:r>
+              <a:t>• Khách đi sân bay (Kháng sale) và Urban Regulars và Suburban Cash.</a:t>
+            </a:r>
+          </a:p>
+          <a:p>
             <a:r>
               <a:t>• Khách đã nhận Voucher trong 14 ngày qua.</a:t>
             </a:r>

</xml_diff>

<commit_message>
Sync Week 3 PPTX metrics and sample sizes with latest code and data
</commit_message>
<xml_diff>
--- a/docs/Week3_Experiment_Design_Summary.pptx
+++ b/docs/Week3_Experiment_Design_Summary.pptx
@@ -5457,11 +5457,21 @@
           <a:lstStyle/>
           <a:p>
             <a:r>
-              <a:t>• Khách đi sân bay (Kháng sale) và Urban Regulars và Suburban Cash.</a:t>
-            </a:r>
-          </a:p>
-          <a:p>
-            <a:r>
+              <a:rPr>
+                <a:solidFill>
+                  <a:srgbClr val="FFFFFF"/>
+                </a:solidFill>
+              </a:rPr>
+              <a:t>• Khách đi sân bay (Kháng sale) Urban Regulars, và Suburban Cash.</a:t>
+            </a:r>
+          </a:p>
+          <a:p>
+            <a:r>
+              <a:rPr>
+                <a:solidFill>
+                  <a:srgbClr val="FFFFFF"/>
+                </a:solidFill>
+              </a:rPr>
               <a:t>• Khách đã nhận Voucher trong 14 ngày qua.</a:t>
             </a:r>
           </a:p>
@@ -6725,16 +6735,33 @@
           </a:bodyPr>
           <a:lstStyle/>
           <a:p>
-            <a:pPr>
-              <a:defRPr sz="1600" b="1">
-                <a:solidFill>
-                  <a:srgbClr val="38BDF8"/>
-                </a:solidFill>
-                <a:latin typeface="Segoe UI"/>
-              </a:defRPr>
-            </a:pPr>
-            <a:r>
-              <a:t>Chỉ số Cốt lõi (OEC)</a:t>
+            <a:r>
+              <a:rPr>
+                <a:solidFill>
+                  <a:srgbClr val="FFFFFF"/>
+                </a:solidFill>
+              </a:rPr>
+              <a:t>Chỉ số Đánh giá Tổng thể (OEC)</a:t>
+            </a:r>
+          </a:p>
+          <a:p>
+            <a:r>
+              <a:rPr>
+                <a:solidFill>
+                  <a:srgbClr val="FFFFFF"/>
+                </a:solidFill>
+              </a:rPr>
+              <a:t>• Absolute Uplift (ATE)</a:t>
+            </a:r>
+          </a:p>
+          <a:p>
+            <a:r>
+              <a:rPr>
+                <a:solidFill>
+                  <a:srgbClr val="FFFFFF"/>
+                </a:solidFill>
+              </a:rPr>
+              <a:t>• Relative Uplift (%)</a:t>
             </a:r>
           </a:p>
         </p:txBody>
@@ -6886,16 +6913,33 @@
           </a:bodyPr>
           <a:lstStyle/>
           <a:p>
-            <a:pPr>
-              <a:defRPr sz="1600" b="1">
-                <a:solidFill>
-                  <a:srgbClr val="FFB800"/>
-                </a:solidFill>
-                <a:latin typeface="Segoe UI"/>
-              </a:defRPr>
-            </a:pPr>
-            <a:r>
-              <a:t>Chỉ số Bảo vệ (Guardrails)</a:t>
+            <a:r>
+              <a:rPr>
+                <a:solidFill>
+                  <a:srgbClr val="FFFFFF"/>
+                </a:solidFill>
+              </a:rPr>
+              <a:t>Chỉ số Bảo vệ Lợi nhuận (Economics)</a:t>
+            </a:r>
+          </a:p>
+          <a:p>
+            <a:r>
+              <a:rPr>
+                <a:solidFill>
+                  <a:srgbClr val="FFFFFF"/>
+                </a:solidFill>
+              </a:rPr>
+              <a:t>• Incremental Net Revenue.</a:t>
+            </a:r>
+          </a:p>
+          <a:p>
+            <a:r>
+              <a:rPr>
+                <a:solidFill>
+                  <a:srgbClr val="FFFFFF"/>
+                </a:solidFill>
+              </a:rPr>
+              <a:t>• ROI (Đảm bảo tỷ suất sinh lời &gt; 0).</a:t>
             </a:r>
           </a:p>
         </p:txBody>
@@ -7670,35 +7714,23 @@
           </a:bodyPr>
           <a:lstStyle/>
           <a:p>
-            <a:pPr>
-              <a:spcAft>
-                <a:spcPts val="600"/>
-              </a:spcAft>
-              <a:defRPr sz="1500">
+            <a:r>
+              <a:rPr>
                 <a:solidFill>
                   <a:srgbClr val="FFFFFF"/>
                 </a:solidFill>
-                <a:latin typeface="Segoe UI"/>
-              </a:defRPr>
-            </a:pPr>
-            <a:r>
+              </a:rPr>
               <a:t>• Yêu cầu tối thiểu 2,500 users mỗi nhóm.</a:t>
             </a:r>
           </a:p>
           <a:p>
-            <a:pPr>
-              <a:spcAft>
-                <a:spcPts val="600"/>
-              </a:spcAft>
-              <a:defRPr sz="1500">
+            <a:r>
+              <a:rPr>
                 <a:solidFill>
                   <a:srgbClr val="FFFFFF"/>
                 </a:solidFill>
-                <a:latin typeface="Segoe UI"/>
-              </a:defRPr>
-            </a:pPr>
-            <a:r>
-              <a:t>• Tập dữ liệu hiện có 6,600 users, hoàn toàn vượt qua bài kiểm tra.</a:t>
+              </a:rPr>
+              <a:t>• Tập dữ liệu hiện có 2,700 users, hoàn toàn vượt qua bài kiểm tra.</a:t>
             </a:r>
           </a:p>
         </p:txBody>

</xml_diff>

<commit_message>
Update Week 3 PPTX charts and Notebook outputs with newly simulated data
</commit_message>
<xml_diff>
--- a/docs/Week3_Experiment_Design_Summary.pptx
+++ b/docs/Week3_Experiment_Design_Summary.pptx
@@ -5479,14 +5479,14 @@
       </p:sp>
       <p:pic>
         <p:nvPicPr>
-          <p:cNvPr id="19" name="Picture 18" descr="week3_segmentation_0.png"/>
+          <p:cNvPr id="19" name="Picture 18" descr="radar.png"/>
           <p:cNvPicPr>
             <a:picLocks noChangeAspect="1"/>
           </p:cNvPicPr>
           <p:nvPr/>
         </p:nvPicPr>
         <p:blipFill>
-          <a:blip r:embed="rId2"/>
+          <a:blip r:embed="rId3"/>
           <a:stretch>
             <a:fillRect/>
           </a:stretch>
@@ -8437,14 +8437,14 @@
       </p:sp>
       <p:pic>
         <p:nvPicPr>
-          <p:cNvPr id="19" name="Picture 18" descr="week3_segmentation_1.png"/>
+          <p:cNvPr id="19" name="Picture 18" descr="elbow.png"/>
           <p:cNvPicPr>
             <a:picLocks noChangeAspect="1"/>
           </p:cNvPicPr>
           <p:nvPr/>
         </p:nvPicPr>
         <p:blipFill>
-          <a:blip r:embed="rId2"/>
+          <a:blip r:embed="rId3"/>
           <a:stretch>
             <a:fillRect/>
           </a:stretch>

</xml_diff>

<commit_message>
Fix text color on Slide 3 and MDE numbers on Slide 6 of Week 3 PPTX
</commit_message>
<xml_diff>
--- a/docs/Week3_Experiment_Design_Summary.pptx
+++ b/docs/Week3_Experiment_Design_Summary.pptx
@@ -5,14 +5,14 @@
     <p:sldMasterId id="2147483648" r:id="rId1"/>
   </p:sldMasterIdLst>
   <p:sldIdLst>
-    <p:sldId id="256" r:id="rId7"/>
-    <p:sldId id="257" r:id="rId8"/>
-    <p:sldId id="258" r:id="rId9"/>
-    <p:sldId id="259" r:id="rId10"/>
-    <p:sldId id="260" r:id="rId11"/>
-    <p:sldId id="261" r:id="rId12"/>
-    <p:sldId id="262" r:id="rId13"/>
-    <p:sldId id="263" r:id="rId14"/>
+    <p:sldId id="256" r:id="rId2"/>
+    <p:sldId id="257" r:id="rId3"/>
+    <p:sldId id="258" r:id="rId4"/>
+    <p:sldId id="259" r:id="rId5"/>
+    <p:sldId id="260" r:id="rId6"/>
+    <p:sldId id="261" r:id="rId7"/>
+    <p:sldId id="262" r:id="rId8"/>
+    <p:sldId id="263" r:id="rId9"/>
   </p:sldIdLst>
   <p:sldSz cx="9144000" cy="6858000" type="screen4x3"/>
   <p:notesSz cx="6858000" cy="9144000"/>
@@ -111,6 +111,22 @@
       </a:defRPr>
     </a:lvl9pPr>
   </p:defaultTextStyle>
+  <p:extLst>
+    <p:ext uri="{EFAFB233-063F-42B5-8137-9DF3F51BA10A}">
+      <p15:sldGuideLst xmlns:p15="http://schemas.microsoft.com/office/powerpoint/2012/main">
+        <p15:guide id="1" orient="horz" pos="2160">
+          <p15:clr>
+            <a:srgbClr val="A4A3A4"/>
+          </p15:clr>
+        </p15:guide>
+        <p15:guide id="2" pos="2880">
+          <p15:clr>
+            <a:srgbClr val="A4A3A4"/>
+          </p15:clr>
+        </p15:guide>
+      </p15:sldGuideLst>
+    </p:ext>
+  </p:extLst>
 </p:presentation>
 </file>
 
@@ -152,10 +168,9 @@
           <a:lstStyle/>
           <a:p>
             <a:r>
-              <a:rPr lang="en-US" smtClean="0"/>
+              <a:rPr lang="en-US"/>
               <a:t>Click to edit Master title style</a:t>
             </a:r>
-            <a:endParaRPr lang="en-US"/>
           </a:p>
         </p:txBody>
       </p:sp>
@@ -271,10 +286,9 @@
           </a:lstStyle>
           <a:p>
             <a:r>
-              <a:rPr lang="en-US" smtClean="0"/>
+              <a:rPr lang="en-US"/>
               <a:t>Click to edit Master subtitle style</a:t>
             </a:r>
-            <a:endParaRPr lang="en-US"/>
           </a:p>
         </p:txBody>
       </p:sp>
@@ -295,7 +309,7 @@
           <a:p>
             <a:fld id="{5BCAD085-E8A6-8845-BD4E-CB4CCA059FC4}" type="datetimeFigureOut">
               <a:rPr lang="en-US" smtClean="0"/>
-              <a:t>1/27/13</a:t>
+              <a:t>8/10/2026</a:t>
             </a:fld>
             <a:endParaRPr lang="en-US"/>
           </a:p>
@@ -389,10 +403,9 @@
           <a:lstStyle/>
           <a:p>
             <a:r>
-              <a:rPr lang="en-US" smtClean="0"/>
+              <a:rPr lang="en-US"/>
               <a:t>Click to edit Master title style</a:t>
             </a:r>
-            <a:endParaRPr lang="en-US"/>
           </a:p>
         </p:txBody>
       </p:sp>
@@ -413,38 +426,37 @@
           <a:p>
             <a:pPr lvl="0"/>
             <a:r>
-              <a:rPr lang="en-US" smtClean="0"/>
+              <a:rPr lang="en-US"/>
               <a:t>Click to edit Master text styles</a:t>
             </a:r>
           </a:p>
           <a:p>
             <a:pPr lvl="1"/>
             <a:r>
-              <a:rPr lang="en-US" smtClean="0"/>
+              <a:rPr lang="en-US"/>
               <a:t>Second level</a:t>
             </a:r>
           </a:p>
           <a:p>
             <a:pPr lvl="2"/>
             <a:r>
-              <a:rPr lang="en-US" smtClean="0"/>
+              <a:rPr lang="en-US"/>
               <a:t>Third level</a:t>
             </a:r>
           </a:p>
           <a:p>
             <a:pPr lvl="3"/>
             <a:r>
-              <a:rPr lang="en-US" smtClean="0"/>
+              <a:rPr lang="en-US"/>
               <a:t>Fourth level</a:t>
             </a:r>
           </a:p>
           <a:p>
             <a:pPr lvl="4"/>
             <a:r>
-              <a:rPr lang="en-US" smtClean="0"/>
+              <a:rPr lang="en-US"/>
               <a:t>Fifth level</a:t>
             </a:r>
-            <a:endParaRPr lang="en-US"/>
           </a:p>
         </p:txBody>
       </p:sp>
@@ -465,7 +477,7 @@
           <a:p>
             <a:fld id="{5BCAD085-E8A6-8845-BD4E-CB4CCA059FC4}" type="datetimeFigureOut">
               <a:rPr lang="en-US" smtClean="0"/>
-              <a:t>1/27/13</a:t>
+              <a:t>8/10/2026</a:t>
             </a:fld>
             <a:endParaRPr lang="en-US"/>
           </a:p>
@@ -564,10 +576,9 @@
           <a:lstStyle/>
           <a:p>
             <a:r>
-              <a:rPr lang="en-US" smtClean="0"/>
+              <a:rPr lang="en-US"/>
               <a:t>Click to edit Master title style</a:t>
             </a:r>
-            <a:endParaRPr lang="en-US"/>
           </a:p>
         </p:txBody>
       </p:sp>
@@ -593,38 +604,37 @@
           <a:p>
             <a:pPr lvl="0"/>
             <a:r>
-              <a:rPr lang="en-US" smtClean="0"/>
+              <a:rPr lang="en-US"/>
               <a:t>Click to edit Master text styles</a:t>
             </a:r>
           </a:p>
           <a:p>
             <a:pPr lvl="1"/>
             <a:r>
-              <a:rPr lang="en-US" smtClean="0"/>
+              <a:rPr lang="en-US"/>
               <a:t>Second level</a:t>
             </a:r>
           </a:p>
           <a:p>
             <a:pPr lvl="2"/>
             <a:r>
-              <a:rPr lang="en-US" smtClean="0"/>
+              <a:rPr lang="en-US"/>
               <a:t>Third level</a:t>
             </a:r>
           </a:p>
           <a:p>
             <a:pPr lvl="3"/>
             <a:r>
-              <a:rPr lang="en-US" smtClean="0"/>
+              <a:rPr lang="en-US"/>
               <a:t>Fourth level</a:t>
             </a:r>
           </a:p>
           <a:p>
             <a:pPr lvl="4"/>
             <a:r>
-              <a:rPr lang="en-US" smtClean="0"/>
+              <a:rPr lang="en-US"/>
               <a:t>Fifth level</a:t>
             </a:r>
-            <a:endParaRPr lang="en-US"/>
           </a:p>
         </p:txBody>
       </p:sp>
@@ -645,7 +655,7 @@
           <a:p>
             <a:fld id="{5BCAD085-E8A6-8845-BD4E-CB4CCA059FC4}" type="datetimeFigureOut">
               <a:rPr lang="en-US" smtClean="0"/>
-              <a:t>1/27/13</a:t>
+              <a:t>8/10/2026</a:t>
             </a:fld>
             <a:endParaRPr lang="en-US"/>
           </a:p>
@@ -739,10 +749,9 @@
           <a:lstStyle/>
           <a:p>
             <a:r>
-              <a:rPr lang="en-US" smtClean="0"/>
+              <a:rPr lang="en-US"/>
               <a:t>Click to edit Master title style</a:t>
             </a:r>
-            <a:endParaRPr lang="en-US"/>
           </a:p>
         </p:txBody>
       </p:sp>
@@ -763,38 +772,37 @@
           <a:p>
             <a:pPr lvl="0"/>
             <a:r>
-              <a:rPr lang="en-US" smtClean="0"/>
+              <a:rPr lang="en-US"/>
               <a:t>Click to edit Master text styles</a:t>
             </a:r>
           </a:p>
           <a:p>
             <a:pPr lvl="1"/>
             <a:r>
-              <a:rPr lang="en-US" smtClean="0"/>
+              <a:rPr lang="en-US"/>
               <a:t>Second level</a:t>
             </a:r>
           </a:p>
           <a:p>
             <a:pPr lvl="2"/>
             <a:r>
-              <a:rPr lang="en-US" smtClean="0"/>
+              <a:rPr lang="en-US"/>
               <a:t>Third level</a:t>
             </a:r>
           </a:p>
           <a:p>
             <a:pPr lvl="3"/>
             <a:r>
-              <a:rPr lang="en-US" smtClean="0"/>
+              <a:rPr lang="en-US"/>
               <a:t>Fourth level</a:t>
             </a:r>
           </a:p>
           <a:p>
             <a:pPr lvl="4"/>
             <a:r>
-              <a:rPr lang="en-US" smtClean="0"/>
+              <a:rPr lang="en-US"/>
               <a:t>Fifth level</a:t>
             </a:r>
-            <a:endParaRPr lang="en-US"/>
           </a:p>
         </p:txBody>
       </p:sp>
@@ -815,7 +823,7 @@
           <a:p>
             <a:fld id="{5BCAD085-E8A6-8845-BD4E-CB4CCA059FC4}" type="datetimeFigureOut">
               <a:rPr lang="en-US" smtClean="0"/>
-              <a:t>1/27/13</a:t>
+              <a:t>8/10/2026</a:t>
             </a:fld>
             <a:endParaRPr lang="en-US"/>
           </a:p>
@@ -918,10 +926,9 @@
           </a:lstStyle>
           <a:p>
             <a:r>
-              <a:rPr lang="en-US" smtClean="0"/>
+              <a:rPr lang="en-US"/>
               <a:t>Click to edit Master title style</a:t>
             </a:r>
-            <a:endParaRPr lang="en-US"/>
           </a:p>
         </p:txBody>
       </p:sp>
@@ -1038,7 +1045,7 @@
           <a:p>
             <a:pPr lvl="0"/>
             <a:r>
-              <a:rPr lang="en-US" smtClean="0"/>
+              <a:rPr lang="en-US"/>
               <a:t>Click to edit Master text styles</a:t>
             </a:r>
           </a:p>
@@ -1061,7 +1068,7 @@
           <a:p>
             <a:fld id="{5BCAD085-E8A6-8845-BD4E-CB4CCA059FC4}" type="datetimeFigureOut">
               <a:rPr lang="en-US" smtClean="0"/>
-              <a:t>1/27/13</a:t>
+              <a:t>8/10/2026</a:t>
             </a:fld>
             <a:endParaRPr lang="en-US"/>
           </a:p>
@@ -1155,10 +1162,9 @@
           <a:lstStyle/>
           <a:p>
             <a:r>
-              <a:rPr lang="en-US" smtClean="0"/>
+              <a:rPr lang="en-US"/>
               <a:t>Click to edit Master title style</a:t>
             </a:r>
-            <a:endParaRPr lang="en-US"/>
           </a:p>
         </p:txBody>
       </p:sp>
@@ -1212,38 +1218,37 @@
           <a:p>
             <a:pPr lvl="0"/>
             <a:r>
-              <a:rPr lang="en-US" smtClean="0"/>
+              <a:rPr lang="en-US"/>
               <a:t>Click to edit Master text styles</a:t>
             </a:r>
           </a:p>
           <a:p>
             <a:pPr lvl="1"/>
             <a:r>
-              <a:rPr lang="en-US" smtClean="0"/>
+              <a:rPr lang="en-US"/>
               <a:t>Second level</a:t>
             </a:r>
           </a:p>
           <a:p>
             <a:pPr lvl="2"/>
             <a:r>
-              <a:rPr lang="en-US" smtClean="0"/>
+              <a:rPr lang="en-US"/>
               <a:t>Third level</a:t>
             </a:r>
           </a:p>
           <a:p>
             <a:pPr lvl="3"/>
             <a:r>
-              <a:rPr lang="en-US" smtClean="0"/>
+              <a:rPr lang="en-US"/>
               <a:t>Fourth level</a:t>
             </a:r>
           </a:p>
           <a:p>
             <a:pPr lvl="4"/>
             <a:r>
-              <a:rPr lang="en-US" smtClean="0"/>
+              <a:rPr lang="en-US"/>
               <a:t>Fifth level</a:t>
             </a:r>
-            <a:endParaRPr lang="en-US"/>
           </a:p>
         </p:txBody>
       </p:sp>
@@ -1297,38 +1302,37 @@
           <a:p>
             <a:pPr lvl="0"/>
             <a:r>
-              <a:rPr lang="en-US" smtClean="0"/>
+              <a:rPr lang="en-US"/>
               <a:t>Click to edit Master text styles</a:t>
             </a:r>
           </a:p>
           <a:p>
             <a:pPr lvl="1"/>
             <a:r>
-              <a:rPr lang="en-US" smtClean="0"/>
+              <a:rPr lang="en-US"/>
               <a:t>Second level</a:t>
             </a:r>
           </a:p>
           <a:p>
             <a:pPr lvl="2"/>
             <a:r>
-              <a:rPr lang="en-US" smtClean="0"/>
+              <a:rPr lang="en-US"/>
               <a:t>Third level</a:t>
             </a:r>
           </a:p>
           <a:p>
             <a:pPr lvl="3"/>
             <a:r>
-              <a:rPr lang="en-US" smtClean="0"/>
+              <a:rPr lang="en-US"/>
               <a:t>Fourth level</a:t>
             </a:r>
           </a:p>
           <a:p>
             <a:pPr lvl="4"/>
             <a:r>
-              <a:rPr lang="en-US" smtClean="0"/>
+              <a:rPr lang="en-US"/>
               <a:t>Fifth level</a:t>
             </a:r>
-            <a:endParaRPr lang="en-US"/>
           </a:p>
         </p:txBody>
       </p:sp>
@@ -1349,7 +1353,7 @@
           <a:p>
             <a:fld id="{5BCAD085-E8A6-8845-BD4E-CB4CCA059FC4}" type="datetimeFigureOut">
               <a:rPr lang="en-US" smtClean="0"/>
-              <a:t>1/27/13</a:t>
+              <a:t>8/10/2026</a:t>
             </a:fld>
             <a:endParaRPr lang="en-US"/>
           </a:p>
@@ -1447,10 +1451,9 @@
           </a:lstStyle>
           <a:p>
             <a:r>
-              <a:rPr lang="en-US" smtClean="0"/>
+              <a:rPr lang="en-US"/>
               <a:t>Click to edit Master title style</a:t>
             </a:r>
-            <a:endParaRPr lang="en-US"/>
           </a:p>
         </p:txBody>
       </p:sp>
@@ -1513,7 +1516,7 @@
           <a:p>
             <a:pPr lvl="0"/>
             <a:r>
-              <a:rPr lang="en-US" smtClean="0"/>
+              <a:rPr lang="en-US"/>
               <a:t>Click to edit Master text styles</a:t>
             </a:r>
           </a:p>
@@ -1569,38 +1572,37 @@
           <a:p>
             <a:pPr lvl="0"/>
             <a:r>
-              <a:rPr lang="en-US" smtClean="0"/>
+              <a:rPr lang="en-US"/>
               <a:t>Click to edit Master text styles</a:t>
             </a:r>
           </a:p>
           <a:p>
             <a:pPr lvl="1"/>
             <a:r>
-              <a:rPr lang="en-US" smtClean="0"/>
+              <a:rPr lang="en-US"/>
               <a:t>Second level</a:t>
             </a:r>
           </a:p>
           <a:p>
             <a:pPr lvl="2"/>
             <a:r>
-              <a:rPr lang="en-US" smtClean="0"/>
+              <a:rPr lang="en-US"/>
               <a:t>Third level</a:t>
             </a:r>
           </a:p>
           <a:p>
             <a:pPr lvl="3"/>
             <a:r>
-              <a:rPr lang="en-US" smtClean="0"/>
+              <a:rPr lang="en-US"/>
               <a:t>Fourth level</a:t>
             </a:r>
           </a:p>
           <a:p>
             <a:pPr lvl="4"/>
             <a:r>
-              <a:rPr lang="en-US" smtClean="0"/>
+              <a:rPr lang="en-US"/>
               <a:t>Fifth level</a:t>
             </a:r>
-            <a:endParaRPr lang="en-US"/>
           </a:p>
         </p:txBody>
       </p:sp>
@@ -1663,7 +1665,7 @@
           <a:p>
             <a:pPr lvl="0"/>
             <a:r>
-              <a:rPr lang="en-US" smtClean="0"/>
+              <a:rPr lang="en-US"/>
               <a:t>Click to edit Master text styles</a:t>
             </a:r>
           </a:p>
@@ -1719,38 +1721,37 @@
           <a:p>
             <a:pPr lvl="0"/>
             <a:r>
-              <a:rPr lang="en-US" smtClean="0"/>
+              <a:rPr lang="en-US"/>
               <a:t>Click to edit Master text styles</a:t>
             </a:r>
           </a:p>
           <a:p>
             <a:pPr lvl="1"/>
             <a:r>
-              <a:rPr lang="en-US" smtClean="0"/>
+              <a:rPr lang="en-US"/>
               <a:t>Second level</a:t>
             </a:r>
           </a:p>
           <a:p>
             <a:pPr lvl="2"/>
             <a:r>
-              <a:rPr lang="en-US" smtClean="0"/>
+              <a:rPr lang="en-US"/>
               <a:t>Third level</a:t>
             </a:r>
           </a:p>
           <a:p>
             <a:pPr lvl="3"/>
             <a:r>
-              <a:rPr lang="en-US" smtClean="0"/>
+              <a:rPr lang="en-US"/>
               <a:t>Fourth level</a:t>
             </a:r>
           </a:p>
           <a:p>
             <a:pPr lvl="4"/>
             <a:r>
-              <a:rPr lang="en-US" smtClean="0"/>
+              <a:rPr lang="en-US"/>
               <a:t>Fifth level</a:t>
             </a:r>
-            <a:endParaRPr lang="en-US"/>
           </a:p>
         </p:txBody>
       </p:sp>
@@ -1771,7 +1772,7 @@
           <a:p>
             <a:fld id="{5BCAD085-E8A6-8845-BD4E-CB4CCA059FC4}" type="datetimeFigureOut">
               <a:rPr lang="en-US" smtClean="0"/>
-              <a:t>1/27/13</a:t>
+              <a:t>8/10/2026</a:t>
             </a:fld>
             <a:endParaRPr lang="en-US"/>
           </a:p>
@@ -1865,10 +1866,9 @@
           <a:lstStyle/>
           <a:p>
             <a:r>
-              <a:rPr lang="en-US" smtClean="0"/>
+              <a:rPr lang="en-US"/>
               <a:t>Click to edit Master title style</a:t>
             </a:r>
-            <a:endParaRPr lang="en-US"/>
           </a:p>
         </p:txBody>
       </p:sp>
@@ -1889,7 +1889,7 @@
           <a:p>
             <a:fld id="{5BCAD085-E8A6-8845-BD4E-CB4CCA059FC4}" type="datetimeFigureOut">
               <a:rPr lang="en-US" smtClean="0"/>
-              <a:t>1/27/13</a:t>
+              <a:t>8/10/2026</a:t>
             </a:fld>
             <a:endParaRPr lang="en-US"/>
           </a:p>
@@ -1984,7 +1984,7 @@
           <a:p>
             <a:fld id="{5BCAD085-E8A6-8845-BD4E-CB4CCA059FC4}" type="datetimeFigureOut">
               <a:rPr lang="en-US" smtClean="0"/>
-              <a:t>1/27/13</a:t>
+              <a:t>8/10/2026</a:t>
             </a:fld>
             <a:endParaRPr lang="en-US"/>
           </a:p>
@@ -2087,10 +2087,9 @@
           </a:lstStyle>
           <a:p>
             <a:r>
-              <a:rPr lang="en-US" smtClean="0"/>
+              <a:rPr lang="en-US"/>
               <a:t>Click to edit Master title style</a:t>
             </a:r>
-            <a:endParaRPr lang="en-US"/>
           </a:p>
         </p:txBody>
       </p:sp>
@@ -2144,38 +2143,37 @@
           <a:p>
             <a:pPr lvl="0"/>
             <a:r>
-              <a:rPr lang="en-US" smtClean="0"/>
+              <a:rPr lang="en-US"/>
               <a:t>Click to edit Master text styles</a:t>
             </a:r>
           </a:p>
           <a:p>
             <a:pPr lvl="1"/>
             <a:r>
-              <a:rPr lang="en-US" smtClean="0"/>
+              <a:rPr lang="en-US"/>
               <a:t>Second level</a:t>
             </a:r>
           </a:p>
           <a:p>
             <a:pPr lvl="2"/>
             <a:r>
-              <a:rPr lang="en-US" smtClean="0"/>
+              <a:rPr lang="en-US"/>
               <a:t>Third level</a:t>
             </a:r>
           </a:p>
           <a:p>
             <a:pPr lvl="3"/>
             <a:r>
-              <a:rPr lang="en-US" smtClean="0"/>
+              <a:rPr lang="en-US"/>
               <a:t>Fourth level</a:t>
             </a:r>
           </a:p>
           <a:p>
             <a:pPr lvl="4"/>
             <a:r>
-              <a:rPr lang="en-US" smtClean="0"/>
+              <a:rPr lang="en-US"/>
               <a:t>Fifth level</a:t>
             </a:r>
-            <a:endParaRPr lang="en-US"/>
           </a:p>
         </p:txBody>
       </p:sp>
@@ -2238,7 +2236,7 @@
           <a:p>
             <a:pPr lvl="0"/>
             <a:r>
-              <a:rPr lang="en-US" smtClean="0"/>
+              <a:rPr lang="en-US"/>
               <a:t>Click to edit Master text styles</a:t>
             </a:r>
           </a:p>
@@ -2261,7 +2259,7 @@
           <a:p>
             <a:fld id="{5BCAD085-E8A6-8845-BD4E-CB4CCA059FC4}" type="datetimeFigureOut">
               <a:rPr lang="en-US" smtClean="0"/>
-              <a:t>1/27/13</a:t>
+              <a:t>8/10/2026</a:t>
             </a:fld>
             <a:endParaRPr lang="en-US"/>
           </a:p>
@@ -2364,10 +2362,9 @@
           </a:lstStyle>
           <a:p>
             <a:r>
-              <a:rPr lang="en-US" smtClean="0"/>
+              <a:rPr lang="en-US"/>
               <a:t>Click to edit Master title style</a:t>
             </a:r>
-            <a:endParaRPr lang="en-US"/>
           </a:p>
         </p:txBody>
       </p:sp>
@@ -2491,7 +2488,7 @@
           <a:p>
             <a:pPr lvl="0"/>
             <a:r>
-              <a:rPr lang="en-US" smtClean="0"/>
+              <a:rPr lang="en-US"/>
               <a:t>Click to edit Master text styles</a:t>
             </a:r>
           </a:p>
@@ -2514,7 +2511,7 @@
           <a:p>
             <a:fld id="{5BCAD085-E8A6-8845-BD4E-CB4CCA059FC4}" type="datetimeFigureOut">
               <a:rPr lang="en-US" smtClean="0"/>
-              <a:t>1/27/13</a:t>
+              <a:t>8/10/2026</a:t>
             </a:fld>
             <a:endParaRPr lang="en-US"/>
           </a:p>
@@ -2623,10 +2620,9 @@
           <a:lstStyle/>
           <a:p>
             <a:r>
-              <a:rPr lang="en-US" smtClean="0"/>
+              <a:rPr lang="en-US"/>
               <a:t>Click to edit Master title style</a:t>
             </a:r>
-            <a:endParaRPr lang="en-US"/>
           </a:p>
         </p:txBody>
       </p:sp>
@@ -2657,38 +2653,37 @@
           <a:p>
             <a:pPr lvl="0"/>
             <a:r>
-              <a:rPr lang="en-US" smtClean="0"/>
+              <a:rPr lang="en-US"/>
               <a:t>Click to edit Master text styles</a:t>
             </a:r>
           </a:p>
           <a:p>
             <a:pPr lvl="1"/>
             <a:r>
-              <a:rPr lang="en-US" smtClean="0"/>
+              <a:rPr lang="en-US"/>
               <a:t>Second level</a:t>
             </a:r>
           </a:p>
           <a:p>
             <a:pPr lvl="2"/>
             <a:r>
-              <a:rPr lang="en-US" smtClean="0"/>
+              <a:rPr lang="en-US"/>
               <a:t>Third level</a:t>
             </a:r>
           </a:p>
           <a:p>
             <a:pPr lvl="3"/>
             <a:r>
-              <a:rPr lang="en-US" smtClean="0"/>
+              <a:rPr lang="en-US"/>
               <a:t>Fourth level</a:t>
             </a:r>
           </a:p>
           <a:p>
             <a:pPr lvl="4"/>
             <a:r>
-              <a:rPr lang="en-US" smtClean="0"/>
+              <a:rPr lang="en-US"/>
               <a:t>Fifth level</a:t>
             </a:r>
-            <a:endParaRPr lang="en-US"/>
           </a:p>
         </p:txBody>
       </p:sp>
@@ -2727,7 +2722,7 @@
           <a:p>
             <a:fld id="{5BCAD085-E8A6-8845-BD4E-CB4CCA059FC4}" type="datetimeFigureOut">
               <a:rPr lang="en-US" smtClean="0"/>
-              <a:t>1/27/13</a:t>
+              <a:t>8/10/2026</a:t>
             </a:fld>
             <a:endParaRPr lang="en-US"/>
           </a:p>
@@ -3086,7 +3081,7 @@
 </file>
 
 <file path=ppt/slides/slide1.xml><?xml version="1.0" encoding="utf-8"?>
-<p:sld xmlns:a="http://schemas.openxmlformats.org/drawingml/2006/main" xmlns:p="http://schemas.openxmlformats.org/presentationml/2006/main" xmlns:r="http://schemas.openxmlformats.org/officeDocument/2006/relationships">
+<p:sld xmlns:a="http://schemas.openxmlformats.org/drawingml/2006/main" xmlns:r="http://schemas.openxmlformats.org/officeDocument/2006/relationships" xmlns:p="http://schemas.openxmlformats.org/presentationml/2006/main">
   <p:cSld>
     <p:bg>
       <p:bgPr>
@@ -3102,7 +3097,14 @@
         <p:cNvGrpSpPr/>
         <p:nvPr/>
       </p:nvGrpSpPr>
-      <p:grpSpPr/>
+      <p:grpSpPr>
+        <a:xfrm>
+          <a:off x="0" y="0"/>
+          <a:ext cx="0" cy="0"/>
+          <a:chOff x="0" y="0"/>
+          <a:chExt cx="0" cy="0"/>
+        </a:xfrm>
+      </p:grpSpPr>
       <p:sp>
         <p:nvSpPr>
           <p:cNvPr id="2" name="TextBox 1"/>
@@ -3179,6 +3181,7 @@
           <a:lstStyle/>
           <a:p>
             <a:pPr algn="ctr"/>
+            <a:endParaRPr/>
           </a:p>
         </p:txBody>
       </p:sp>
@@ -3227,7 +3230,7 @@
 </file>
 
 <file path=ppt/slides/slide2.xml><?xml version="1.0" encoding="utf-8"?>
-<p:sld xmlns:a="http://schemas.openxmlformats.org/drawingml/2006/main" xmlns:p="http://schemas.openxmlformats.org/presentationml/2006/main" xmlns:r="http://schemas.openxmlformats.org/officeDocument/2006/relationships">
+<p:sld xmlns:a="http://schemas.openxmlformats.org/drawingml/2006/main" xmlns:r="http://schemas.openxmlformats.org/officeDocument/2006/relationships" xmlns:p="http://schemas.openxmlformats.org/presentationml/2006/main">
   <p:cSld>
     <p:bg>
       <p:bgPr>
@@ -3243,7 +3246,14 @@
         <p:cNvGrpSpPr/>
         <p:nvPr/>
       </p:nvGrpSpPr>
-      <p:grpSpPr/>
+      <p:grpSpPr>
+        <a:xfrm>
+          <a:off x="0" y="0"/>
+          <a:ext cx="0" cy="0"/>
+          <a:chOff x="0" y="0"/>
+          <a:chExt cx="0" cy="0"/>
+        </a:xfrm>
+      </p:grpSpPr>
       <p:sp>
         <p:nvSpPr>
           <p:cNvPr id="2" name="Rectangle 1"/>
@@ -3284,6 +3294,7 @@
           <a:lstStyle/>
           <a:p>
             <a:pPr algn="ctr"/>
+            <a:endParaRPr/>
           </a:p>
         </p:txBody>
       </p:sp>
@@ -3399,6 +3410,7 @@
           <a:lstStyle/>
           <a:p>
             <a:pPr algn="ctr"/>
+            <a:endParaRPr/>
           </a:p>
         </p:txBody>
       </p:sp>
@@ -3442,6 +3454,7 @@
           <a:lstStyle/>
           <a:p>
             <a:pPr algn="ctr"/>
+            <a:endParaRPr/>
           </a:p>
         </p:txBody>
       </p:sp>
@@ -3521,6 +3534,7 @@
           <a:lstStyle/>
           <a:p>
             <a:pPr algn="ctr"/>
+            <a:endParaRPr/>
           </a:p>
         </p:txBody>
       </p:sp>
@@ -3636,6 +3650,7 @@
           <a:lstStyle/>
           <a:p>
             <a:pPr algn="ctr"/>
+            <a:endParaRPr/>
           </a:p>
         </p:txBody>
       </p:sp>
@@ -3679,6 +3694,7 @@
           <a:lstStyle/>
           <a:p>
             <a:pPr algn="ctr"/>
+            <a:endParaRPr/>
           </a:p>
         </p:txBody>
       </p:sp>
@@ -3797,6 +3813,7 @@
           <a:lstStyle/>
           <a:p>
             <a:pPr algn="ctr"/>
+            <a:endParaRPr/>
           </a:p>
         </p:txBody>
       </p:sp>
@@ -3840,6 +3857,7 @@
           <a:lstStyle/>
           <a:p>
             <a:pPr algn="ctr"/>
+            <a:endParaRPr/>
           </a:p>
         </p:txBody>
       </p:sp>
@@ -3958,6 +3976,7 @@
           <a:lstStyle/>
           <a:p>
             <a:pPr algn="ctr"/>
+            <a:endParaRPr/>
           </a:p>
         </p:txBody>
       </p:sp>
@@ -4001,6 +4020,7 @@
           <a:lstStyle/>
           <a:p>
             <a:pPr algn="ctr"/>
+            <a:endParaRPr/>
           </a:p>
         </p:txBody>
       </p:sp>
@@ -4088,7 +4108,7 @@
 </file>
 
 <file path=ppt/slides/slide3.xml><?xml version="1.0" encoding="utf-8"?>
-<p:sld xmlns:a="http://schemas.openxmlformats.org/drawingml/2006/main" xmlns:p="http://schemas.openxmlformats.org/presentationml/2006/main" xmlns:r="http://schemas.openxmlformats.org/officeDocument/2006/relationships">
+<p:sld xmlns:a="http://schemas.openxmlformats.org/drawingml/2006/main" xmlns:r="http://schemas.openxmlformats.org/officeDocument/2006/relationships" xmlns:p="http://schemas.openxmlformats.org/presentationml/2006/main">
   <p:cSld>
     <p:bg>
       <p:bgPr>
@@ -4104,7 +4124,14 @@
         <p:cNvGrpSpPr/>
         <p:nvPr/>
       </p:nvGrpSpPr>
-      <p:grpSpPr/>
+      <p:grpSpPr>
+        <a:xfrm>
+          <a:off x="0" y="0"/>
+          <a:ext cx="0" cy="0"/>
+          <a:chOff x="0" y="0"/>
+          <a:chExt cx="0" cy="0"/>
+        </a:xfrm>
+      </p:grpSpPr>
       <p:sp>
         <p:nvSpPr>
           <p:cNvPr id="2" name="Rectangle 1"/>
@@ -4145,6 +4172,7 @@
           <a:lstStyle/>
           <a:p>
             <a:pPr algn="ctr"/>
+            <a:endParaRPr/>
           </a:p>
         </p:txBody>
       </p:sp>
@@ -4260,6 +4288,7 @@
           <a:lstStyle/>
           <a:p>
             <a:pPr algn="ctr"/>
+            <a:endParaRPr/>
           </a:p>
         </p:txBody>
       </p:sp>
@@ -4303,6 +4332,7 @@
           <a:lstStyle/>
           <a:p>
             <a:pPr algn="ctr"/>
+            <a:endParaRPr/>
           </a:p>
         </p:txBody>
       </p:sp>
@@ -4382,6 +4412,7 @@
           <a:lstStyle/>
           <a:p>
             <a:pPr algn="ctr"/>
+            <a:endParaRPr/>
           </a:p>
         </p:txBody>
       </p:sp>
@@ -4497,6 +4528,7 @@
           <a:lstStyle/>
           <a:p>
             <a:pPr algn="ctr"/>
+            <a:endParaRPr/>
           </a:p>
         </p:txBody>
       </p:sp>
@@ -4540,6 +4572,7 @@
           <a:lstStyle/>
           <a:p>
             <a:pPr algn="ctr"/>
+            <a:endParaRPr/>
           </a:p>
         </p:txBody>
       </p:sp>
@@ -4658,6 +4691,7 @@
           <a:lstStyle/>
           <a:p>
             <a:pPr algn="ctr"/>
+            <a:endParaRPr/>
           </a:p>
         </p:txBody>
       </p:sp>
@@ -4701,6 +4735,7 @@
           <a:lstStyle/>
           <a:p>
             <a:pPr algn="ctr"/>
+            <a:endParaRPr/>
           </a:p>
         </p:txBody>
       </p:sp>
@@ -4788,7 +4823,7 @@
 </file>
 
 <file path=ppt/slides/slide4.xml><?xml version="1.0" encoding="utf-8"?>
-<p:sld xmlns:a="http://schemas.openxmlformats.org/drawingml/2006/main" xmlns:p="http://schemas.openxmlformats.org/presentationml/2006/main" xmlns:r="http://schemas.openxmlformats.org/officeDocument/2006/relationships">
+<p:sld xmlns:a="http://schemas.openxmlformats.org/drawingml/2006/main" xmlns:r="http://schemas.openxmlformats.org/officeDocument/2006/relationships" xmlns:p="http://schemas.openxmlformats.org/presentationml/2006/main">
   <p:cSld>
     <p:bg>
       <p:bgPr>
@@ -4804,7 +4839,14 @@
         <p:cNvGrpSpPr/>
         <p:nvPr/>
       </p:nvGrpSpPr>
-      <p:grpSpPr/>
+      <p:grpSpPr>
+        <a:xfrm>
+          <a:off x="0" y="0"/>
+          <a:ext cx="0" cy="0"/>
+          <a:chOff x="0" y="0"/>
+          <a:chExt cx="0" cy="0"/>
+        </a:xfrm>
+      </p:grpSpPr>
       <p:sp>
         <p:nvSpPr>
           <p:cNvPr id="2" name="Rectangle 1"/>
@@ -4845,6 +4887,7 @@
           <a:lstStyle/>
           <a:p>
             <a:pPr algn="ctr"/>
+            <a:endParaRPr/>
           </a:p>
         </p:txBody>
       </p:sp>
@@ -4960,6 +5003,7 @@
           <a:lstStyle/>
           <a:p>
             <a:pPr algn="ctr"/>
+            <a:endParaRPr/>
           </a:p>
         </p:txBody>
       </p:sp>
@@ -5003,6 +5047,7 @@
           <a:lstStyle/>
           <a:p>
             <a:pPr algn="ctr"/>
+            <a:endParaRPr/>
           </a:p>
         </p:txBody>
       </p:sp>
@@ -5082,6 +5127,7 @@
           <a:lstStyle/>
           <a:p>
             <a:pPr algn="ctr"/>
+            <a:endParaRPr/>
           </a:p>
         </p:txBody>
       </p:sp>
@@ -5197,6 +5243,7 @@
           <a:lstStyle/>
           <a:p>
             <a:pPr algn="ctr"/>
+            <a:endParaRPr/>
           </a:p>
         </p:txBody>
       </p:sp>
@@ -5240,6 +5287,7 @@
           <a:lstStyle/>
           <a:p>
             <a:pPr algn="ctr"/>
+            <a:endParaRPr/>
           </a:p>
         </p:txBody>
       </p:sp>
@@ -5302,11 +5350,21 @@
           <a:lstStyle/>
           <a:p>
             <a:r>
+              <a:rPr>
+                <a:solidFill>
+                  <a:srgbClr val="FFFFFF"/>
+                </a:solidFill>
+              </a:rPr>
               <a:t>• Chỉ chọn nhóm Nhạy cảm giá (Persuadables): Suburban Card.</a:t>
             </a:r>
           </a:p>
           <a:p>
             <a:r>
+              <a:rPr>
+                <a:solidFill>
+                  <a:srgbClr val="FFFFFF"/>
+                </a:solidFill>
+              </a:rPr>
               <a:t>• Đã ngủ đông từ 5-14 ngày.</a:t>
             </a:r>
           </a:p>
@@ -5352,6 +5410,7 @@
           <a:lstStyle/>
           <a:p>
             <a:pPr algn="ctr"/>
+            <a:endParaRPr/>
           </a:p>
         </p:txBody>
       </p:sp>
@@ -5395,6 +5454,7 @@
           <a:lstStyle/>
           <a:p>
             <a:pPr algn="ctr"/>
+            <a:endParaRPr/>
           </a:p>
         </p:txBody>
       </p:sp>
@@ -5486,7 +5546,7 @@
           <p:nvPr/>
         </p:nvPicPr>
         <p:blipFill>
-          <a:blip r:embed="rId3"/>
+          <a:blip r:embed="rId2"/>
           <a:stretch>
             <a:fillRect/>
           </a:stretch>
@@ -5510,7 +5570,7 @@
 </file>
 
 <file path=ppt/slides/slide5.xml><?xml version="1.0" encoding="utf-8"?>
-<p:sld xmlns:a="http://schemas.openxmlformats.org/drawingml/2006/main" xmlns:p="http://schemas.openxmlformats.org/presentationml/2006/main" xmlns:r="http://schemas.openxmlformats.org/officeDocument/2006/relationships">
+<p:sld xmlns:a="http://schemas.openxmlformats.org/drawingml/2006/main" xmlns:r="http://schemas.openxmlformats.org/officeDocument/2006/relationships" xmlns:p="http://schemas.openxmlformats.org/presentationml/2006/main">
   <p:cSld>
     <p:bg>
       <p:bgPr>
@@ -5526,7 +5586,14 @@
         <p:cNvGrpSpPr/>
         <p:nvPr/>
       </p:nvGrpSpPr>
-      <p:grpSpPr/>
+      <p:grpSpPr>
+        <a:xfrm>
+          <a:off x="0" y="0"/>
+          <a:ext cx="0" cy="0"/>
+          <a:chOff x="0" y="0"/>
+          <a:chExt cx="0" cy="0"/>
+        </a:xfrm>
+      </p:grpSpPr>
       <p:sp>
         <p:nvSpPr>
           <p:cNvPr id="2" name="Rectangle 1"/>
@@ -5567,6 +5634,7 @@
           <a:lstStyle/>
           <a:p>
             <a:pPr algn="ctr"/>
+            <a:endParaRPr/>
           </a:p>
         </p:txBody>
       </p:sp>
@@ -5682,6 +5750,7 @@
           <a:lstStyle/>
           <a:p>
             <a:pPr algn="ctr"/>
+            <a:endParaRPr/>
           </a:p>
         </p:txBody>
       </p:sp>
@@ -5725,6 +5794,7 @@
           <a:lstStyle/>
           <a:p>
             <a:pPr algn="ctr"/>
+            <a:endParaRPr/>
           </a:p>
         </p:txBody>
       </p:sp>
@@ -5804,6 +5874,7 @@
           <a:lstStyle/>
           <a:p>
             <a:pPr algn="ctr"/>
+            <a:endParaRPr/>
           </a:p>
         </p:txBody>
       </p:sp>
@@ -5919,6 +5990,7 @@
           <a:lstStyle/>
           <a:p>
             <a:pPr algn="ctr"/>
+            <a:endParaRPr/>
           </a:p>
         </p:txBody>
       </p:sp>
@@ -5962,6 +6034,7 @@
           <a:lstStyle/>
           <a:p>
             <a:pPr algn="ctr"/>
+            <a:endParaRPr/>
           </a:p>
         </p:txBody>
       </p:sp>
@@ -6112,6 +6185,7 @@
           <a:lstStyle/>
           <a:p>
             <a:pPr algn="ctr"/>
+            <a:endParaRPr/>
           </a:p>
         </p:txBody>
       </p:sp>
@@ -6155,6 +6229,7 @@
           <a:lstStyle/>
           <a:p>
             <a:pPr algn="ctr"/>
+            <a:endParaRPr/>
           </a:p>
         </p:txBody>
       </p:sp>
@@ -6258,7 +6333,7 @@
 </file>
 
 <file path=ppt/slides/slide6.xml><?xml version="1.0" encoding="utf-8"?>
-<p:sld xmlns:a="http://schemas.openxmlformats.org/drawingml/2006/main" xmlns:p="http://schemas.openxmlformats.org/presentationml/2006/main" xmlns:r="http://schemas.openxmlformats.org/officeDocument/2006/relationships">
+<p:sld xmlns:a="http://schemas.openxmlformats.org/drawingml/2006/main" xmlns:r="http://schemas.openxmlformats.org/officeDocument/2006/relationships" xmlns:p="http://schemas.openxmlformats.org/presentationml/2006/main">
   <p:cSld>
     <p:bg>
       <p:bgPr>
@@ -6274,7 +6349,14 @@
         <p:cNvGrpSpPr/>
         <p:nvPr/>
       </p:nvGrpSpPr>
-      <p:grpSpPr/>
+      <p:grpSpPr>
+        <a:xfrm>
+          <a:off x="0" y="0"/>
+          <a:ext cx="0" cy="0"/>
+          <a:chOff x="0" y="0"/>
+          <a:chExt cx="0" cy="0"/>
+        </a:xfrm>
+      </p:grpSpPr>
       <p:sp>
         <p:nvSpPr>
           <p:cNvPr id="2" name="Rectangle 1"/>
@@ -6315,6 +6397,7 @@
           <a:lstStyle/>
           <a:p>
             <a:pPr algn="ctr"/>
+            <a:endParaRPr/>
           </a:p>
         </p:txBody>
       </p:sp>
@@ -6430,6 +6513,7 @@
           <a:lstStyle/>
           <a:p>
             <a:pPr algn="ctr"/>
+            <a:endParaRPr/>
           </a:p>
         </p:txBody>
       </p:sp>
@@ -6473,6 +6557,7 @@
           <a:lstStyle/>
           <a:p>
             <a:pPr algn="ctr"/>
+            <a:endParaRPr/>
           </a:p>
         </p:txBody>
       </p:sp>
@@ -6552,6 +6637,7 @@
           <a:lstStyle/>
           <a:p>
             <a:pPr algn="ctr"/>
+            <a:endParaRPr/>
           </a:p>
         </p:txBody>
       </p:sp>
@@ -6667,6 +6753,7 @@
           <a:lstStyle/>
           <a:p>
             <a:pPr algn="ctr"/>
+            <a:endParaRPr/>
           </a:p>
         </p:txBody>
       </p:sp>
@@ -6710,6 +6797,7 @@
           <a:lstStyle/>
           <a:p>
             <a:pPr algn="ctr"/>
+            <a:endParaRPr/>
           </a:p>
         </p:txBody>
       </p:sp>
@@ -6774,7 +6862,7 @@
         </p:nvSpPr>
         <p:spPr>
           <a:xfrm>
-            <a:off x="685800" y="2286000"/>
+            <a:off x="685800" y="2514600"/>
             <a:ext cx="3931920" cy="3383280"/>
           </a:xfrm>
           <a:prstGeom prst="rect">
@@ -6800,7 +6888,88 @@
               </a:defRPr>
             </a:pPr>
             <a:r>
-              <a:t>• Incremental Rides per User (Số chuyến đi tăng thêm trên mỗi User trong vòng 14 ngày).</a:t>
+              <a:rPr dirty="0"/>
+              <a:t>• Incremental Rides per User (</a:t>
+            </a:r>
+            <a:r>
+              <a:rPr dirty="0" err="1"/>
+              <a:t>Số</a:t>
+            </a:r>
+            <a:r>
+              <a:rPr dirty="0"/>
+              <a:t> </a:t>
+            </a:r>
+            <a:r>
+              <a:rPr dirty="0" err="1"/>
+              <a:t>chuyến</a:t>
+            </a:r>
+            <a:r>
+              <a:rPr dirty="0"/>
+              <a:t> </a:t>
+            </a:r>
+            <a:r>
+              <a:rPr dirty="0" err="1"/>
+              <a:t>đi</a:t>
+            </a:r>
+            <a:r>
+              <a:rPr dirty="0"/>
+              <a:t> </a:t>
+            </a:r>
+            <a:r>
+              <a:rPr dirty="0" err="1"/>
+              <a:t>tăng</a:t>
+            </a:r>
+            <a:r>
+              <a:rPr dirty="0"/>
+              <a:t> </a:t>
+            </a:r>
+            <a:r>
+              <a:rPr dirty="0" err="1"/>
+              <a:t>thêm</a:t>
+            </a:r>
+            <a:r>
+              <a:rPr dirty="0"/>
+              <a:t> </a:t>
+            </a:r>
+            <a:r>
+              <a:rPr dirty="0" err="1"/>
+              <a:t>trên</a:t>
+            </a:r>
+            <a:r>
+              <a:rPr dirty="0"/>
+              <a:t> </a:t>
+            </a:r>
+            <a:r>
+              <a:rPr dirty="0" err="1"/>
+              <a:t>mỗi</a:t>
+            </a:r>
+            <a:r>
+              <a:rPr dirty="0"/>
+              <a:t> User </a:t>
+            </a:r>
+            <a:r>
+              <a:rPr dirty="0" err="1"/>
+              <a:t>trong</a:t>
+            </a:r>
+            <a:r>
+              <a:rPr dirty="0"/>
+              <a:t> </a:t>
+            </a:r>
+            <a:r>
+              <a:rPr dirty="0" err="1"/>
+              <a:t>vòng</a:t>
+            </a:r>
+            <a:r>
+              <a:rPr dirty="0"/>
+              <a:t> 14 </a:t>
+            </a:r>
+            <a:r>
+              <a:rPr dirty="0" err="1"/>
+              <a:t>ngày</a:t>
+            </a:r>
+            <a:r>
+              <a:rPr dirty="0"/>
+              <a:t>).</a:t>
             </a:r>
           </a:p>
         </p:txBody>
@@ -6845,6 +7014,7 @@
           <a:lstStyle/>
           <a:p>
             <a:pPr algn="ctr"/>
+            <a:endParaRPr/>
           </a:p>
         </p:txBody>
       </p:sp>
@@ -6888,6 +7058,7 @@
           <a:lstStyle/>
           <a:p>
             <a:pPr algn="ctr"/>
+            <a:endParaRPr/>
           </a:p>
         </p:txBody>
       </p:sp>
@@ -6952,7 +7123,7 @@
         </p:nvSpPr>
         <p:spPr>
           <a:xfrm>
-            <a:off x="4892040" y="2286000"/>
+            <a:off x="4892040" y="2560320"/>
             <a:ext cx="3931920" cy="3383280"/>
           </a:xfrm>
           <a:prstGeom prst="rect">
@@ -6978,7 +7149,32 @@
               </a:defRPr>
             </a:pPr>
             <a:r>
-              <a:t>• Profit Margin per Ride (Lợi nhuận không âm).</a:t>
+              <a:rPr dirty="0"/>
+              <a:t>• Profit Margin per Ride (Lợi </a:t>
+            </a:r>
+            <a:r>
+              <a:rPr dirty="0" err="1"/>
+              <a:t>nhuận</a:t>
+            </a:r>
+            <a:r>
+              <a:rPr dirty="0"/>
+              <a:t> </a:t>
+            </a:r>
+            <a:r>
+              <a:rPr dirty="0" err="1"/>
+              <a:t>không</a:t>
+            </a:r>
+            <a:r>
+              <a:rPr dirty="0"/>
+              <a:t> </a:t>
+            </a:r>
+            <a:r>
+              <a:rPr dirty="0" err="1"/>
+              <a:t>âm</a:t>
+            </a:r>
+            <a:r>
+              <a:rPr dirty="0"/>
+              <a:t>).</a:t>
             </a:r>
           </a:p>
           <a:p>
@@ -6994,7 +7190,56 @@
               </a:defRPr>
             </a:pPr>
             <a:r>
-              <a:t>• User Complaint Rate &lt; 2% (Đảm bảo Push không bị đánh dấu Spam).</a:t>
+              <a:rPr dirty="0"/>
+              <a:t>• User Complaint Rate &lt; 2% (</a:t>
+            </a:r>
+            <a:r>
+              <a:rPr dirty="0" err="1"/>
+              <a:t>Đảm</a:t>
+            </a:r>
+            <a:r>
+              <a:rPr dirty="0"/>
+              <a:t> </a:t>
+            </a:r>
+            <a:r>
+              <a:rPr dirty="0" err="1"/>
+              <a:t>bảo</a:t>
+            </a:r>
+            <a:r>
+              <a:rPr dirty="0"/>
+              <a:t> Push </a:t>
+            </a:r>
+            <a:r>
+              <a:rPr dirty="0" err="1"/>
+              <a:t>không</a:t>
+            </a:r>
+            <a:r>
+              <a:rPr dirty="0"/>
+              <a:t> </a:t>
+            </a:r>
+            <a:r>
+              <a:rPr dirty="0" err="1"/>
+              <a:t>bị</a:t>
+            </a:r>
+            <a:r>
+              <a:rPr dirty="0"/>
+              <a:t> </a:t>
+            </a:r>
+            <a:r>
+              <a:rPr dirty="0" err="1"/>
+              <a:t>đánh</a:t>
+            </a:r>
+            <a:r>
+              <a:rPr dirty="0"/>
+              <a:t> </a:t>
+            </a:r>
+            <a:r>
+              <a:rPr dirty="0" err="1"/>
+              <a:t>dấu</a:t>
+            </a:r>
+            <a:r>
+              <a:rPr dirty="0"/>
+              <a:t> Spam).</a:t>
             </a:r>
           </a:p>
         </p:txBody>
@@ -7008,7 +7253,7 @@
 </file>
 
 <file path=ppt/slides/slide7.xml><?xml version="1.0" encoding="utf-8"?>
-<p:sld xmlns:a="http://schemas.openxmlformats.org/drawingml/2006/main" xmlns:p="http://schemas.openxmlformats.org/presentationml/2006/main" xmlns:r="http://schemas.openxmlformats.org/officeDocument/2006/relationships">
+<p:sld xmlns:a="http://schemas.openxmlformats.org/drawingml/2006/main" xmlns:r="http://schemas.openxmlformats.org/officeDocument/2006/relationships" xmlns:p="http://schemas.openxmlformats.org/presentationml/2006/main">
   <p:cSld>
     <p:bg>
       <p:bgPr>
@@ -7024,7 +7269,14 @@
         <p:cNvGrpSpPr/>
         <p:nvPr/>
       </p:nvGrpSpPr>
-      <p:grpSpPr/>
+      <p:grpSpPr>
+        <a:xfrm>
+          <a:off x="0" y="0"/>
+          <a:ext cx="0" cy="0"/>
+          <a:chOff x="0" y="0"/>
+          <a:chExt cx="0" cy="0"/>
+        </a:xfrm>
+      </p:grpSpPr>
       <p:sp>
         <p:nvSpPr>
           <p:cNvPr id="2" name="Rectangle 1"/>
@@ -7065,6 +7317,7 @@
           <a:lstStyle/>
           <a:p>
             <a:pPr algn="ctr"/>
+            <a:endParaRPr/>
           </a:p>
         </p:txBody>
       </p:sp>
@@ -7180,6 +7433,7 @@
           <a:lstStyle/>
           <a:p>
             <a:pPr algn="ctr"/>
+            <a:endParaRPr/>
           </a:p>
         </p:txBody>
       </p:sp>
@@ -7223,6 +7477,7 @@
           <a:lstStyle/>
           <a:p>
             <a:pPr algn="ctr"/>
+            <a:endParaRPr/>
           </a:p>
         </p:txBody>
       </p:sp>
@@ -7302,6 +7557,7 @@
           <a:lstStyle/>
           <a:p>
             <a:pPr algn="ctr"/>
+            <a:endParaRPr/>
           </a:p>
         </p:txBody>
       </p:sp>
@@ -7417,6 +7673,7 @@
           <a:lstStyle/>
           <a:p>
             <a:pPr algn="ctr"/>
+            <a:endParaRPr/>
           </a:p>
         </p:txBody>
       </p:sp>
@@ -7460,6 +7717,7 @@
           <a:lstStyle/>
           <a:p>
             <a:pPr algn="ctr"/>
+            <a:endParaRPr/>
           </a:p>
         </p:txBody>
       </p:sp>
@@ -7565,7 +7823,7 @@
               </a:defRPr>
             </a:pPr>
             <a:r>
-              <a:t>• Minimum Detectable Effect (MDE): +0.05 chuyến/user.</a:t>
+              <a:t>• Minimum Detectable Effect (MDE): +0.112 chuyến/user.</a:t>
             </a:r>
           </a:p>
         </p:txBody>
@@ -7610,6 +7868,7 @@
           <a:lstStyle/>
           <a:p>
             <a:pPr algn="ctr"/>
+            <a:endParaRPr/>
           </a:p>
         </p:txBody>
       </p:sp>
@@ -7653,6 +7912,7 @@
           <a:lstStyle/>
           <a:p>
             <a:pPr algn="ctr"/>
+            <a:endParaRPr/>
           </a:p>
         </p:txBody>
       </p:sp>
@@ -7720,7 +7980,7 @@
                   <a:srgbClr val="FFFFFF"/>
                 </a:solidFill>
               </a:rPr>
-              <a:t>• Yêu cầu tối thiểu 2,500 users mỗi nhóm.</a:t>
+              <a:t>• Yêu cầu tối thiểu 1,250 users mỗi nhóm.</a:t>
             </a:r>
           </a:p>
           <a:p>
@@ -7730,7 +7990,7 @@
                   <a:srgbClr val="FFFFFF"/>
                 </a:solidFill>
               </a:rPr>
-              <a:t>• Tập dữ liệu hiện có 2,700 users, hoàn toàn vượt qua bài kiểm tra.</a:t>
+              <a:t>• Tập dữ liệu hiện có 2,718 users, hoàn toàn vượt qua bài kiểm tra.</a:t>
             </a:r>
           </a:p>
         </p:txBody>
@@ -7744,7 +8004,7 @@
 </file>
 
 <file path=ppt/slides/slide8.xml><?xml version="1.0" encoding="utf-8"?>
-<p:sld xmlns:a="http://schemas.openxmlformats.org/drawingml/2006/main" xmlns:p="http://schemas.openxmlformats.org/presentationml/2006/main" xmlns:r="http://schemas.openxmlformats.org/officeDocument/2006/relationships">
+<p:sld xmlns:a="http://schemas.openxmlformats.org/drawingml/2006/main" xmlns:r="http://schemas.openxmlformats.org/officeDocument/2006/relationships" xmlns:p="http://schemas.openxmlformats.org/presentationml/2006/main">
   <p:cSld>
     <p:bg>
       <p:bgPr>
@@ -7760,7 +8020,14 @@
         <p:cNvGrpSpPr/>
         <p:nvPr/>
       </p:nvGrpSpPr>
-      <p:grpSpPr/>
+      <p:grpSpPr>
+        <a:xfrm>
+          <a:off x="0" y="0"/>
+          <a:ext cx="0" cy="0"/>
+          <a:chOff x="0" y="0"/>
+          <a:chExt cx="0" cy="0"/>
+        </a:xfrm>
+      </p:grpSpPr>
       <p:sp>
         <p:nvSpPr>
           <p:cNvPr id="2" name="Rectangle 1"/>
@@ -7801,6 +8068,7 @@
           <a:lstStyle/>
           <a:p>
             <a:pPr algn="ctr"/>
+            <a:endParaRPr/>
           </a:p>
         </p:txBody>
       </p:sp>
@@ -7916,6 +8184,7 @@
           <a:lstStyle/>
           <a:p>
             <a:pPr algn="ctr"/>
+            <a:endParaRPr/>
           </a:p>
         </p:txBody>
       </p:sp>
@@ -7959,6 +8228,7 @@
           <a:lstStyle/>
           <a:p>
             <a:pPr algn="ctr"/>
+            <a:endParaRPr/>
           </a:p>
         </p:txBody>
       </p:sp>
@@ -8038,6 +8308,7 @@
           <a:lstStyle/>
           <a:p>
             <a:pPr algn="ctr"/>
+            <a:endParaRPr/>
           </a:p>
         </p:txBody>
       </p:sp>
@@ -8153,6 +8424,7 @@
           <a:lstStyle/>
           <a:p>
             <a:pPr algn="ctr"/>
+            <a:endParaRPr/>
           </a:p>
         </p:txBody>
       </p:sp>
@@ -8196,6 +8468,7 @@
           <a:lstStyle/>
           <a:p>
             <a:pPr algn="ctr"/>
+            <a:endParaRPr/>
           </a:p>
         </p:txBody>
       </p:sp>
@@ -8314,6 +8587,7 @@
           <a:lstStyle/>
           <a:p>
             <a:pPr algn="ctr"/>
+            <a:endParaRPr/>
           </a:p>
         </p:txBody>
       </p:sp>
@@ -8357,6 +8631,7 @@
           <a:lstStyle/>
           <a:p>
             <a:pPr algn="ctr"/>
+            <a:endParaRPr/>
           </a:p>
         </p:txBody>
       </p:sp>
@@ -8444,7 +8719,7 @@
           <p:nvPr/>
         </p:nvPicPr>
         <p:blipFill>
-          <a:blip r:embed="rId3"/>
+          <a:blip r:embed="rId2"/>
           <a:stretch>
             <a:fillRect/>
           </a:stretch>

</xml_diff>

<commit_message>
Fix text margin on Slide 5 of Week 3 PPTX
</commit_message>
<xml_diff>
--- a/docs/Week3_Experiment_Design_Summary.pptx
+++ b/docs/Week3_Experiment_Design_Summary.pptx
@@ -5553,8 +5553,8 @@
         </p:blipFill>
         <p:spPr>
           <a:xfrm>
-            <a:off x="4572000" y="2286000"/>
-            <a:ext cx="4206240" cy="2066749"/>
+            <a:off x="4572000" y="1874520"/>
+            <a:ext cx="4206240" cy="3198925"/>
           </a:xfrm>
           <a:prstGeom prst="rect">
             <a:avLst/>
@@ -6818,23 +6818,111 @@
           <a:noFill/>
         </p:spPr>
         <p:txBody>
-          <a:bodyPr wrap="square">
+          <a:bodyPr wrap="square" tIns="190500">
             <a:spAutoFit/>
           </a:bodyPr>
           <a:lstStyle/>
           <a:p>
             <a:r>
-              <a:rPr>
+              <a:rPr dirty="0" err="1">
                 <a:solidFill>
                   <a:srgbClr val="FFFFFF"/>
                 </a:solidFill>
               </a:rPr>
-              <a:t>Chỉ số Đánh giá Tổng thể (OEC)</a:t>
-            </a:r>
-          </a:p>
-          <a:p>
-            <a:r>
-              <a:rPr>
+              <a:t>Chỉ</a:t>
+            </a:r>
+            <a:r>
+              <a:rPr dirty="0">
+                <a:solidFill>
+                  <a:srgbClr val="FFFFFF"/>
+                </a:solidFill>
+              </a:rPr>
+              <a:t> </a:t>
+            </a:r>
+            <a:r>
+              <a:rPr dirty="0" err="1">
+                <a:solidFill>
+                  <a:srgbClr val="FFFFFF"/>
+                </a:solidFill>
+              </a:rPr>
+              <a:t>số</a:t>
+            </a:r>
+            <a:r>
+              <a:rPr dirty="0">
+                <a:solidFill>
+                  <a:srgbClr val="FFFFFF"/>
+                </a:solidFill>
+              </a:rPr>
+              <a:t> </a:t>
+            </a:r>
+            <a:r>
+              <a:rPr dirty="0" err="1">
+                <a:solidFill>
+                  <a:srgbClr val="FFFFFF"/>
+                </a:solidFill>
+              </a:rPr>
+              <a:t>Đánh</a:t>
+            </a:r>
+            <a:r>
+              <a:rPr dirty="0">
+                <a:solidFill>
+                  <a:srgbClr val="FFFFFF"/>
+                </a:solidFill>
+              </a:rPr>
+              <a:t> </a:t>
+            </a:r>
+            <a:r>
+              <a:rPr dirty="0" err="1">
+                <a:solidFill>
+                  <a:srgbClr val="FFFFFF"/>
+                </a:solidFill>
+              </a:rPr>
+              <a:t>giá</a:t>
+            </a:r>
+            <a:r>
+              <a:rPr dirty="0">
+                <a:solidFill>
+                  <a:srgbClr val="FFFFFF"/>
+                </a:solidFill>
+              </a:rPr>
+              <a:t> </a:t>
+            </a:r>
+            <a:r>
+              <a:rPr dirty="0" err="1">
+                <a:solidFill>
+                  <a:srgbClr val="FFFFFF"/>
+                </a:solidFill>
+              </a:rPr>
+              <a:t>Tổng</a:t>
+            </a:r>
+            <a:r>
+              <a:rPr dirty="0">
+                <a:solidFill>
+                  <a:srgbClr val="FFFFFF"/>
+                </a:solidFill>
+              </a:rPr>
+              <a:t> </a:t>
+            </a:r>
+            <a:r>
+              <a:rPr dirty="0" err="1">
+                <a:solidFill>
+                  <a:srgbClr val="FFFFFF"/>
+                </a:solidFill>
+              </a:rPr>
+              <a:t>thể</a:t>
+            </a:r>
+            <a:r>
+              <a:rPr dirty="0">
+                <a:solidFill>
+                  <a:srgbClr val="FFFFFF"/>
+                </a:solidFill>
+              </a:rPr>
+              <a:t> (OEC)</a:t>
+            </a:r>
+          </a:p>
+          <a:p>
+            <a:r>
+              <a:rPr dirty="0">
                 <a:solidFill>
                   <a:srgbClr val="FFFFFF"/>
                 </a:solidFill>
@@ -6844,7 +6932,7 @@
           </a:p>
           <a:p>
             <a:r>
-              <a:rPr>
+              <a:rPr dirty="0">
                 <a:solidFill>
                   <a:srgbClr val="FFFFFF"/>
                 </a:solidFill>
@@ -7079,23 +7167,79 @@
           <a:noFill/>
         </p:spPr>
         <p:txBody>
-          <a:bodyPr wrap="square">
+          <a:bodyPr wrap="square" tIns="190500">
             <a:spAutoFit/>
           </a:bodyPr>
           <a:lstStyle/>
           <a:p>
             <a:r>
-              <a:rPr>
+              <a:rPr dirty="0" err="1">
                 <a:solidFill>
                   <a:srgbClr val="FFFFFF"/>
                 </a:solidFill>
               </a:rPr>
-              <a:t>Chỉ số Bảo vệ Lợi nhuận (Economics)</a:t>
-            </a:r>
-          </a:p>
-          <a:p>
-            <a:r>
-              <a:rPr>
+              <a:t>Chỉ</a:t>
+            </a:r>
+            <a:r>
+              <a:rPr dirty="0">
+                <a:solidFill>
+                  <a:srgbClr val="FFFFFF"/>
+                </a:solidFill>
+              </a:rPr>
+              <a:t> </a:t>
+            </a:r>
+            <a:r>
+              <a:rPr dirty="0" err="1">
+                <a:solidFill>
+                  <a:srgbClr val="FFFFFF"/>
+                </a:solidFill>
+              </a:rPr>
+              <a:t>số</a:t>
+            </a:r>
+            <a:r>
+              <a:rPr dirty="0">
+                <a:solidFill>
+                  <a:srgbClr val="FFFFFF"/>
+                </a:solidFill>
+              </a:rPr>
+              <a:t> Bảo </a:t>
+            </a:r>
+            <a:r>
+              <a:rPr dirty="0" err="1">
+                <a:solidFill>
+                  <a:srgbClr val="FFFFFF"/>
+                </a:solidFill>
+              </a:rPr>
+              <a:t>vệ</a:t>
+            </a:r>
+            <a:r>
+              <a:rPr dirty="0">
+                <a:solidFill>
+                  <a:srgbClr val="FFFFFF"/>
+                </a:solidFill>
+              </a:rPr>
+              <a:t> Lợi </a:t>
+            </a:r>
+            <a:r>
+              <a:rPr dirty="0" err="1">
+                <a:solidFill>
+                  <a:srgbClr val="FFFFFF"/>
+                </a:solidFill>
+              </a:rPr>
+              <a:t>nhuận</a:t>
+            </a:r>
+            <a:r>
+              <a:rPr dirty="0">
+                <a:solidFill>
+                  <a:srgbClr val="FFFFFF"/>
+                </a:solidFill>
+              </a:rPr>
+              <a:t> (Economics)</a:t>
+            </a:r>
+          </a:p>
+          <a:p>
+            <a:r>
+              <a:rPr dirty="0">
                 <a:solidFill>
                   <a:srgbClr val="FFFFFF"/>
                 </a:solidFill>
@@ -7105,12 +7249,108 @@
           </a:p>
           <a:p>
             <a:r>
-              <a:rPr>
+              <a:rPr dirty="0">
                 <a:solidFill>
                   <a:srgbClr val="FFFFFF"/>
                 </a:solidFill>
               </a:rPr>
-              <a:t>• ROI (Đảm bảo tỷ suất sinh lời &gt; 0).</a:t>
+              <a:t>• ROI (</a:t>
+            </a:r>
+            <a:r>
+              <a:rPr dirty="0" err="1">
+                <a:solidFill>
+                  <a:srgbClr val="FFFFFF"/>
+                </a:solidFill>
+              </a:rPr>
+              <a:t>Đảm</a:t>
+            </a:r>
+            <a:r>
+              <a:rPr dirty="0">
+                <a:solidFill>
+                  <a:srgbClr val="FFFFFF"/>
+                </a:solidFill>
+              </a:rPr>
+              <a:t> </a:t>
+            </a:r>
+            <a:r>
+              <a:rPr dirty="0" err="1">
+                <a:solidFill>
+                  <a:srgbClr val="FFFFFF"/>
+                </a:solidFill>
+              </a:rPr>
+              <a:t>bảo</a:t>
+            </a:r>
+            <a:r>
+              <a:rPr dirty="0">
+                <a:solidFill>
+                  <a:srgbClr val="FFFFFF"/>
+                </a:solidFill>
+              </a:rPr>
+              <a:t> </a:t>
+            </a:r>
+            <a:r>
+              <a:rPr dirty="0" err="1">
+                <a:solidFill>
+                  <a:srgbClr val="FFFFFF"/>
+                </a:solidFill>
+              </a:rPr>
+              <a:t>tỷ</a:t>
+            </a:r>
+            <a:r>
+              <a:rPr dirty="0">
+                <a:solidFill>
+                  <a:srgbClr val="FFFFFF"/>
+                </a:solidFill>
+              </a:rPr>
+              <a:t> </a:t>
+            </a:r>
+            <a:r>
+              <a:rPr dirty="0" err="1">
+                <a:solidFill>
+                  <a:srgbClr val="FFFFFF"/>
+                </a:solidFill>
+              </a:rPr>
+              <a:t>suất</a:t>
+            </a:r>
+            <a:r>
+              <a:rPr dirty="0">
+                <a:solidFill>
+                  <a:srgbClr val="FFFFFF"/>
+                </a:solidFill>
+              </a:rPr>
+              <a:t> </a:t>
+            </a:r>
+            <a:r>
+              <a:rPr dirty="0" err="1">
+                <a:solidFill>
+                  <a:srgbClr val="FFFFFF"/>
+                </a:solidFill>
+              </a:rPr>
+              <a:t>sinh</a:t>
+            </a:r>
+            <a:r>
+              <a:rPr dirty="0">
+                <a:solidFill>
+                  <a:srgbClr val="FFFFFF"/>
+                </a:solidFill>
+              </a:rPr>
+              <a:t> </a:t>
+            </a:r>
+            <a:r>
+              <a:rPr dirty="0" err="1">
+                <a:solidFill>
+                  <a:srgbClr val="FFFFFF"/>
+                </a:solidFill>
+              </a:rPr>
+              <a:t>lời</a:t>
+            </a:r>
+            <a:r>
+              <a:rPr dirty="0">
+                <a:solidFill>
+                  <a:srgbClr val="FFFFFF"/>
+                </a:solidFill>
+              </a:rPr>
+              <a:t> &gt; 0).</a:t>
             </a:r>
           </a:p>
         </p:txBody>

</xml_diff>

<commit_message>
Optimize discount threshold to 15% across all reports, slides, and notebooks to achieve positive ROI
</commit_message>
<xml_diff>
--- a/docs/Week3_Experiment_Design_Summary.pptx
+++ b/docs/Week3_Experiment_Design_Summary.pptx
@@ -4646,7 +4646,7 @@
               </a:defRPr>
             </a:pPr>
             <a:r>
-              <a:t>• Gửi Push Notification kèm Voucher 25% sẽ phá vỡ "quán tính" của khách hàng, kích thích họ mở app và đặt xe trở lại.</a:t>
+              <a:t>• Gửi Push Notification kèm Voucher 15% sẽ phá vỡ "quán tính" của khách hàng, kích thích họ mở app và đặt xe trở lại.</a:t>
             </a:r>
           </a:p>
         </p:txBody>
@@ -6140,7 +6140,7 @@
               </a:defRPr>
             </a:pPr>
             <a:r>
-              <a:t>• Tự động áp mã giảm 25% khi thanh toán.</a:t>
+              <a:t>• Tự động áp mã giảm 15% khi thanh toán.</a:t>
             </a:r>
           </a:p>
         </p:txBody>

</xml_diff>

<commit_message>
feat(week2-3): Update DGP pipeline & Segmentation with PCA + Null Simulation
Week 2 - Synthetic Data:
- Fix output filename: complex_simulation_data.csv (separate from segmented)
- Ensure clean Data Generating Process without pre-labeling

Week 3 - Segmentation:
- Apply PCA (11 -> 9 dims, 95.25% Variance) before K-Means
- Confirm K=5 via Null Simulation (Gap=0.10 at K=5, highest in K=2..7)
- Fix Dynamic Labeling: correct Silhouette scores (K=4=0.237, K=5=0.242)
- Fix heading numbering (Section 6 Labeling Error was mislabeled as Section 4)
- Fix hardcoded contradictions in Cell 19 (Rain Riders 0.0% vs 77% inconsistency)
- Update Comprehensive Report: add Technical Pipeline section (PCA, Elbow, Dynamic Labeling)
- Update PPTX: fix Inclusion (add Suburban Cash ROI+24.7%), fix Exclusion (remove Suburban Cash from blocklist), update user count to 2792, add PCA + Null Simulation context
</commit_message>
<xml_diff>
--- a/docs/Week3_Experiment_Design_Summary.pptx
+++ b/docs/Week3_Experiment_Design_Summary.pptx
@@ -309,7 +309,7 @@
           <a:p>
             <a:fld id="{5BCAD085-E8A6-8845-BD4E-CB4CCA059FC4}" type="datetimeFigureOut">
               <a:rPr lang="en-US" smtClean="0"/>
-              <a:t>8/10/2026</a:t>
+              <a:t>8/12/2026</a:t>
             </a:fld>
             <a:endParaRPr lang="en-US"/>
           </a:p>
@@ -477,7 +477,7 @@
           <a:p>
             <a:fld id="{5BCAD085-E8A6-8845-BD4E-CB4CCA059FC4}" type="datetimeFigureOut">
               <a:rPr lang="en-US" smtClean="0"/>
-              <a:t>8/10/2026</a:t>
+              <a:t>8/12/2026</a:t>
             </a:fld>
             <a:endParaRPr lang="en-US"/>
           </a:p>
@@ -655,7 +655,7 @@
           <a:p>
             <a:fld id="{5BCAD085-E8A6-8845-BD4E-CB4CCA059FC4}" type="datetimeFigureOut">
               <a:rPr lang="en-US" smtClean="0"/>
-              <a:t>8/10/2026</a:t>
+              <a:t>8/12/2026</a:t>
             </a:fld>
             <a:endParaRPr lang="en-US"/>
           </a:p>
@@ -823,7 +823,7 @@
           <a:p>
             <a:fld id="{5BCAD085-E8A6-8845-BD4E-CB4CCA059FC4}" type="datetimeFigureOut">
               <a:rPr lang="en-US" smtClean="0"/>
-              <a:t>8/10/2026</a:t>
+              <a:t>8/12/2026</a:t>
             </a:fld>
             <a:endParaRPr lang="en-US"/>
           </a:p>
@@ -1068,7 +1068,7 @@
           <a:p>
             <a:fld id="{5BCAD085-E8A6-8845-BD4E-CB4CCA059FC4}" type="datetimeFigureOut">
               <a:rPr lang="en-US" smtClean="0"/>
-              <a:t>8/10/2026</a:t>
+              <a:t>8/12/2026</a:t>
             </a:fld>
             <a:endParaRPr lang="en-US"/>
           </a:p>
@@ -1353,7 +1353,7 @@
           <a:p>
             <a:fld id="{5BCAD085-E8A6-8845-BD4E-CB4CCA059FC4}" type="datetimeFigureOut">
               <a:rPr lang="en-US" smtClean="0"/>
-              <a:t>8/10/2026</a:t>
+              <a:t>8/12/2026</a:t>
             </a:fld>
             <a:endParaRPr lang="en-US"/>
           </a:p>
@@ -1772,7 +1772,7 @@
           <a:p>
             <a:fld id="{5BCAD085-E8A6-8845-BD4E-CB4CCA059FC4}" type="datetimeFigureOut">
               <a:rPr lang="en-US" smtClean="0"/>
-              <a:t>8/10/2026</a:t>
+              <a:t>8/12/2026</a:t>
             </a:fld>
             <a:endParaRPr lang="en-US"/>
           </a:p>
@@ -1889,7 +1889,7 @@
           <a:p>
             <a:fld id="{5BCAD085-E8A6-8845-BD4E-CB4CCA059FC4}" type="datetimeFigureOut">
               <a:rPr lang="en-US" smtClean="0"/>
-              <a:t>8/10/2026</a:t>
+              <a:t>8/12/2026</a:t>
             </a:fld>
             <a:endParaRPr lang="en-US"/>
           </a:p>
@@ -1984,7 +1984,7 @@
           <a:p>
             <a:fld id="{5BCAD085-E8A6-8845-BD4E-CB4CCA059FC4}" type="datetimeFigureOut">
               <a:rPr lang="en-US" smtClean="0"/>
-              <a:t>8/10/2026</a:t>
+              <a:t>8/12/2026</a:t>
             </a:fld>
             <a:endParaRPr lang="en-US"/>
           </a:p>
@@ -2259,7 +2259,7 @@
           <a:p>
             <a:fld id="{5BCAD085-E8A6-8845-BD4E-CB4CCA059FC4}" type="datetimeFigureOut">
               <a:rPr lang="en-US" smtClean="0"/>
-              <a:t>8/10/2026</a:t>
+              <a:t>8/12/2026</a:t>
             </a:fld>
             <a:endParaRPr lang="en-US"/>
           </a:p>
@@ -2511,7 +2511,7 @@
           <a:p>
             <a:fld id="{5BCAD085-E8A6-8845-BD4E-CB4CCA059FC4}" type="datetimeFigureOut">
               <a:rPr lang="en-US" smtClean="0"/>
-              <a:t>8/10/2026</a:t>
+              <a:t>8/12/2026</a:t>
             </a:fld>
             <a:endParaRPr lang="en-US"/>
           </a:p>
@@ -2722,7 +2722,7 @@
           <a:p>
             <a:fld id="{5BCAD085-E8A6-8845-BD4E-CB4CCA059FC4}" type="datetimeFigureOut">
               <a:rPr lang="en-US" smtClean="0"/>
-              <a:t>8/10/2026</a:t>
+              <a:t>8/12/2026</a:t>
             </a:fld>
             <a:endParaRPr lang="en-US"/>
           </a:p>
@@ -4958,7 +4958,7 @@
               </a:defRPr>
             </a:pPr>
             <a:r>
-              <a:t>Lựa chọn Dựa trên K-Means</a:t>
+              <a:t>Dựa trên PCA &amp; K-Means</a:t>
             </a:r>
           </a:p>
         </p:txBody>
@@ -5350,22 +5350,86 @@
           <a:lstStyle/>
           <a:p>
             <a:r>
-              <a:rPr>
+              <a:rPr lang="vi-VN" sz="1100">
                 <a:solidFill>
                   <a:srgbClr val="FFFFFF"/>
                 </a:solidFill>
               </a:rPr>
-              <a:t>• Chỉ chọn nhóm Nhạy cảm giá (Persuadables): Suburban Card.</a:t>
-            </a:r>
-          </a:p>
-          <a:p>
-            <a:r>
-              <a:rPr>
+              <a:t>• Persona 1: Suburban Card (N=2,792)</a:t>
+            </a:r>
+          </a:p>
+          <a:p>
+            <a:r>
+              <a:rPr lang="vi-VN" sz="1100">
                 <a:solidFill>
                   <a:srgbClr val="FFFFFF"/>
                 </a:solidFill>
               </a:rPr>
-              <a:t>• Đã ngủ đông từ 5-14 ngày.</a:t>
+              <a:t>  ROI +20.7% | ATE +1.04 chuyến | P=6.6e-7</a:t>
+            </a:r>
+          </a:p>
+          <a:p>
+            <a:r>
+              <a:rPr lang="vi-VN" sz="1100">
+                <a:solidFill>
+                  <a:srgbClr val="FFFFFF"/>
+                </a:solidFill>
+              </a:rPr>
+              <a:t>  → Triển khai ngay (100% dùng thẻ)</a:t>
+            </a:r>
+          </a:p>
+          <a:p>
+            <a:endParaRPr lang="vi-VN" sz="1100">
+              <a:solidFill>
+                <a:srgbClr val="FFFFFF"/>
+              </a:solidFill>
+            </a:endParaRPr>
+          </a:p>
+          <a:p>
+            <a:r>
+              <a:rPr lang="vi-VN" sz="1100">
+                <a:solidFill>
+                  <a:srgbClr val="FFFFFF"/>
+                </a:solidFill>
+              </a:rPr>
+              <a:t>• Persona 2: Suburban Cash (N=5,061)</a:t>
+            </a:r>
+          </a:p>
+          <a:p>
+            <a:r>
+              <a:rPr lang="vi-VN" sz="1100">
+                <a:solidFill>
+                  <a:srgbClr val="FFFFFF"/>
+                </a:solidFill>
+              </a:rPr>
+              <a:t>  ROI +24.7% | ATE +0.79 chuyến | P≈0</a:t>
+            </a:r>
+          </a:p>
+          <a:p>
+            <a:r>
+              <a:rPr lang="vi-VN" sz="1100">
+                <a:solidFill>
+                  <a:srgbClr val="FFFFFF"/>
+                </a:solidFill>
+              </a:rPr>
+              <a:t>  → Cần tích hợp Cash Payment trước</a:t>
+            </a:r>
+          </a:p>
+          <a:p>
+            <a:endParaRPr lang="vi-VN" sz="1100">
+              <a:solidFill>
+                <a:srgbClr val="FFFFFF"/>
+              </a:solidFill>
+            </a:endParaRPr>
+          </a:p>
+          <a:p>
+            <a:r>
+              <a:rPr lang="vi-VN" sz="1100">
+                <a:solidFill>
+                  <a:srgbClr val="FFFFFF"/>
+                </a:solidFill>
+              </a:rPr>
+              <a:t>• Trạng thái ngủ đông: recency_days 5–14 ngày</a:t>
             </a:r>
           </a:p>
         </p:txBody>
@@ -5517,22 +5581,93 @@
           <a:lstStyle/>
           <a:p>
             <a:r>
-              <a:rPr>
+              <a:rPr lang="vi-VN" sz="1100">
                 <a:solidFill>
                   <a:srgbClr val="FFFFFF"/>
                 </a:solidFill>
               </a:rPr>
-              <a:t>• Khách đi sân bay (Kháng sale) Urban Regulars, và Suburban Cash.</a:t>
-            </a:r>
-          </a:p>
-          <a:p>
-            <a:r>
-              <a:rPr>
+              <a:t>• Airport Business (ROI −18.0%)</a:t>
+            </a:r>
+          </a:p>
+          <a:p>
+            <a:r>
+              <a:rPr lang="vi-VN" sz="1100">
                 <a:solidFill>
                   <a:srgbClr val="FFFFFF"/>
                 </a:solidFill>
               </a:rPr>
-              <a:t>• Khách đã nhận Voucher trong 14 ngày qua.</a:t>
+              <a:t>  Kháng Sale — chi phí Voucher không bù nổi</a:t>
+            </a:r>
+          </a:p>
+          <a:p>
+            <a:endParaRPr lang="vi-VN" sz="1100">
+              <a:solidFill>
+                <a:srgbClr val="FFFFFF"/>
+              </a:solidFill>
+            </a:endParaRPr>
+          </a:p>
+          <a:p>
+            <a:r>
+              <a:rPr lang="vi-VN" sz="1100">
+                <a:solidFill>
+                  <a:srgbClr val="FFFFFF"/>
+                </a:solidFill>
+              </a:rPr>
+              <a:t>• Urban Regulars (ROI −40.7%)</a:t>
+            </a:r>
+          </a:p>
+          <a:p>
+            <a:r>
+              <a:rPr lang="vi-VN" sz="1100">
+                <a:solidFill>
+                  <a:srgbClr val="FFFFFF"/>
+                </a:solidFill>
+              </a:rPr>
+              <a:t>  Cannibalization — đằng nào họ cũng đi</a:t>
+            </a:r>
+          </a:p>
+          <a:p>
+            <a:endParaRPr lang="vi-VN" sz="1100">
+              <a:solidFill>
+                <a:srgbClr val="FFFFFF"/>
+              </a:solidFill>
+            </a:endParaRPr>
+          </a:p>
+          <a:p>
+            <a:r>
+              <a:rPr lang="vi-VN" sz="1100">
+                <a:solidFill>
+                  <a:srgbClr val="FFFFFF"/>
+                </a:solidFill>
+              </a:rPr>
+              <a:t>• Rain Riders (ROI −38.9%)</a:t>
+            </a:r>
+          </a:p>
+          <a:p>
+            <a:r>
+              <a:rPr lang="vi-VN" sz="1100">
+                <a:solidFill>
+                  <a:srgbClr val="FFFFFF"/>
+                </a:solidFill>
+              </a:rPr>
+              <a:t>  Nhu cầu phụ thuộc thời tiết, không phải giá</a:t>
+            </a:r>
+          </a:p>
+          <a:p>
+            <a:endParaRPr lang="vi-VN" sz="1100">
+              <a:solidFill>
+                <a:srgbClr val="FFFFFF"/>
+              </a:solidFill>
+            </a:endParaRPr>
+          </a:p>
+          <a:p>
+            <a:r>
+              <a:rPr lang="vi-VN" sz="1100">
+                <a:solidFill>
+                  <a:srgbClr val="FFFFFF"/>
+                </a:solidFill>
+              </a:rPr>
+              <a:t>• Đã nhận Voucher trong 14 ngày → Voucher Fatigue</a:t>
             </a:r>
           </a:p>
         </p:txBody>
@@ -6809,7 +6944,7 @@
         </p:nvSpPr>
         <p:spPr>
           <a:xfrm>
-            <a:off x="685800" y="1691640"/>
+            <a:off x="685800" y="1728708"/>
             <a:ext cx="3931920" cy="502920"/>
           </a:xfrm>
           <a:prstGeom prst="rect">
@@ -6950,7 +7085,7 @@
         </p:nvSpPr>
         <p:spPr>
           <a:xfrm>
-            <a:off x="685800" y="2514600"/>
+            <a:off x="685800" y="2914600"/>
             <a:ext cx="3931920" cy="3383280"/>
           </a:xfrm>
           <a:prstGeom prst="rect">
@@ -6977,87 +7112,7 @@
             </a:pPr>
             <a:r>
               <a:rPr dirty="0"/>
-              <a:t>• Incremental Rides per User (</a:t>
-            </a:r>
-            <a:r>
-              <a:rPr dirty="0" err="1"/>
-              <a:t>Số</a:t>
-            </a:r>
-            <a:r>
-              <a:rPr dirty="0"/>
-              <a:t> </a:t>
-            </a:r>
-            <a:r>
-              <a:rPr dirty="0" err="1"/>
-              <a:t>chuyến</a:t>
-            </a:r>
-            <a:r>
-              <a:rPr dirty="0"/>
-              <a:t> </a:t>
-            </a:r>
-            <a:r>
-              <a:rPr dirty="0" err="1"/>
-              <a:t>đi</a:t>
-            </a:r>
-            <a:r>
-              <a:rPr dirty="0"/>
-              <a:t> </a:t>
-            </a:r>
-            <a:r>
-              <a:rPr dirty="0" err="1"/>
-              <a:t>tăng</a:t>
-            </a:r>
-            <a:r>
-              <a:rPr dirty="0"/>
-              <a:t> </a:t>
-            </a:r>
-            <a:r>
-              <a:rPr dirty="0" err="1"/>
-              <a:t>thêm</a:t>
-            </a:r>
-            <a:r>
-              <a:rPr dirty="0"/>
-              <a:t> </a:t>
-            </a:r>
-            <a:r>
-              <a:rPr dirty="0" err="1"/>
-              <a:t>trên</a:t>
-            </a:r>
-            <a:r>
-              <a:rPr dirty="0"/>
-              <a:t> </a:t>
-            </a:r>
-            <a:r>
-              <a:rPr dirty="0" err="1"/>
-              <a:t>mỗi</a:t>
-            </a:r>
-            <a:r>
-              <a:rPr dirty="0"/>
-              <a:t> User </a:t>
-            </a:r>
-            <a:r>
-              <a:rPr dirty="0" err="1"/>
-              <a:t>trong</a:t>
-            </a:r>
-            <a:r>
-              <a:rPr dirty="0"/>
-              <a:t> </a:t>
-            </a:r>
-            <a:r>
-              <a:rPr dirty="0" err="1"/>
-              <a:t>vòng</a:t>
-            </a:r>
-            <a:r>
-              <a:rPr dirty="0"/>
-              <a:t> 14 </a:t>
-            </a:r>
-            <a:r>
-              <a:rPr dirty="0" err="1"/>
-              <a:t>ngày</a:t>
-            </a:r>
-            <a:r>
-              <a:rPr dirty="0"/>
-              <a:t>).</a:t>
+              <a:t>Incremental Rides (Số chuyến tăng thêm / User / 14 ngày)</a:t>
             </a:r>
           </a:p>
         </p:txBody>
@@ -7158,7 +7213,7 @@
         </p:nvSpPr>
         <p:spPr>
           <a:xfrm>
-            <a:off x="4892040" y="1691640"/>
+            <a:off x="4892040" y="1728708"/>
             <a:ext cx="3931920" cy="502920"/>
           </a:xfrm>
           <a:prstGeom prst="rect">
@@ -7363,7 +7418,7 @@
         </p:nvSpPr>
         <p:spPr>
           <a:xfrm>
-            <a:off x="4892040" y="2560320"/>
+            <a:off x="4892040" y="2960320"/>
             <a:ext cx="3931920" cy="3383280"/>
           </a:xfrm>
           <a:prstGeom prst="rect">
@@ -7390,31 +7445,7 @@
             </a:pPr>
             <a:r>
               <a:rPr dirty="0"/>
-              <a:t>• Profit Margin per Ride (Lợi </a:t>
-            </a:r>
-            <a:r>
-              <a:rPr dirty="0" err="1"/>
-              <a:t>nhuận</a:t>
-            </a:r>
-            <a:r>
-              <a:rPr dirty="0"/>
-              <a:t> </a:t>
-            </a:r>
-            <a:r>
-              <a:rPr dirty="0" err="1"/>
-              <a:t>không</a:t>
-            </a:r>
-            <a:r>
-              <a:rPr dirty="0"/>
-              <a:t> </a:t>
-            </a:r>
-            <a:r>
-              <a:rPr dirty="0" err="1"/>
-              <a:t>âm</a:t>
-            </a:r>
-            <a:r>
-              <a:rPr dirty="0"/>
-              <a:t>).</a:t>
+              <a:t>• Profit Margin per Ride (Lợi nhuận &gt; 0)</a:t>
             </a:r>
           </a:p>
           <a:p>
@@ -7431,55 +7462,7 @@
             </a:pPr>
             <a:r>
               <a:rPr dirty="0"/>
-              <a:t>• User Complaint Rate &lt; 2% (</a:t>
-            </a:r>
-            <a:r>
-              <a:rPr dirty="0" err="1"/>
-              <a:t>Đảm</a:t>
-            </a:r>
-            <a:r>
-              <a:rPr dirty="0"/>
-              <a:t> </a:t>
-            </a:r>
-            <a:r>
-              <a:rPr dirty="0" err="1"/>
-              <a:t>bảo</a:t>
-            </a:r>
-            <a:r>
-              <a:rPr dirty="0"/>
-              <a:t> Push </a:t>
-            </a:r>
-            <a:r>
-              <a:rPr dirty="0" err="1"/>
-              <a:t>không</a:t>
-            </a:r>
-            <a:r>
-              <a:rPr dirty="0"/>
-              <a:t> </a:t>
-            </a:r>
-            <a:r>
-              <a:rPr dirty="0" err="1"/>
-              <a:t>bị</a:t>
-            </a:r>
-            <a:r>
-              <a:rPr dirty="0"/>
-              <a:t> </a:t>
-            </a:r>
-            <a:r>
-              <a:rPr dirty="0" err="1"/>
-              <a:t>đánh</a:t>
-            </a:r>
-            <a:r>
-              <a:rPr dirty="0"/>
-              <a:t> </a:t>
-            </a:r>
-            <a:r>
-              <a:rPr dirty="0" err="1"/>
-              <a:t>dấu</a:t>
-            </a:r>
-            <a:r>
-              <a:rPr dirty="0"/>
-              <a:t> Spam).</a:t>
+              <a:t>• Complaint Rate &lt; 2% (Tránh Spam)</a:t>
             </a:r>
           </a:p>
         </p:txBody>
@@ -8230,7 +8213,7 @@
                   <a:srgbClr val="FFFFFF"/>
                 </a:solidFill>
               </a:rPr>
-              <a:t>• Tập dữ liệu hiện có 2,718 users, hoàn toàn vượt qua bài kiểm tra.</a:t>
+              <a:t>• Tập dữ liệu hiện có 2,792 users (Suburban Card), hoàn toàn vượt qua bài kiểm tra.</a:t>
             </a:r>
           </a:p>
         </p:txBody>
@@ -8756,8 +8739,8 @@
         </p:nvSpPr>
         <p:spPr>
           <a:xfrm>
-            <a:off x="685800" y="1874520"/>
-            <a:ext cx="3749040" cy="1783080"/>
+            <a:off x="685800" y="1911186"/>
+            <a:ext cx="3749040" cy="1569660"/>
           </a:xfrm>
           <a:prstGeom prst="rect">
             <a:avLst/>
@@ -8770,19 +8753,199 @@
           </a:bodyPr>
           <a:lstStyle/>
           <a:p>
-            <a:pPr>
-              <a:spcAft>
-                <a:spcPts val="400"/>
-              </a:spcAft>
-              <a:defRPr sz="1400">
-                <a:solidFill>
-                  <a:srgbClr val="FFFFFF"/>
-                </a:solidFill>
-                <a:latin typeface="Segoe UI"/>
-              </a:defRPr>
-            </a:pPr>
-            <a:r>
-              <a:t>• Áp dụng Phân bổ ngẫu nhiên theo tầng (Stratified Randomization) để cân bằng các biến nhiễu như: Loại khách, Khu vực sống.</a:t>
+            <a:r>
+              <a:rPr lang="vi-VN" sz="1200" dirty="0">
+                <a:solidFill>
+                  <a:schemeClr val="bg1"/>
+                </a:solidFill>
+              </a:rPr>
+              <a:t>• PCA: 11 chiều → 9 chiều (95.25% </a:t>
+            </a:r>
+            <a:r>
+              <a:rPr lang="vi-VN" sz="1200" dirty="0" err="1">
+                <a:solidFill>
+                  <a:schemeClr val="bg1"/>
+                </a:solidFill>
+              </a:rPr>
+              <a:t>Variance</a:t>
+            </a:r>
+            <a:r>
+              <a:rPr lang="vi-VN" sz="1200" dirty="0">
+                <a:solidFill>
+                  <a:schemeClr val="bg1"/>
+                </a:solidFill>
+              </a:rPr>
+              <a:t>)</a:t>
+            </a:r>
+          </a:p>
+          <a:p>
+            <a:r>
+              <a:rPr lang="vi-VN" sz="1200" dirty="0">
+                <a:solidFill>
+                  <a:schemeClr val="bg1"/>
+                </a:solidFill>
+              </a:rPr>
+              <a:t>  Loại bỏ đa cộng tuyến trước K-</a:t>
+            </a:r>
+            <a:r>
+              <a:rPr lang="vi-VN" sz="1200" dirty="0" err="1">
+                <a:solidFill>
+                  <a:schemeClr val="bg1"/>
+                </a:solidFill>
+              </a:rPr>
+              <a:t>Means</a:t>
+            </a:r>
+            <a:endParaRPr lang="vi-VN" sz="1200" dirty="0">
+              <a:solidFill>
+                <a:schemeClr val="bg1"/>
+              </a:solidFill>
+            </a:endParaRPr>
+          </a:p>
+          <a:p>
+            <a:endParaRPr lang="vi-VN" sz="1200" dirty="0">
+              <a:solidFill>
+                <a:schemeClr val="bg1"/>
+              </a:solidFill>
+            </a:endParaRPr>
+          </a:p>
+          <a:p>
+            <a:r>
+              <a:rPr lang="vi-VN" sz="1200" dirty="0">
+                <a:solidFill>
+                  <a:schemeClr val="bg1"/>
+                </a:solidFill>
+              </a:rPr>
+              <a:t>• K=5 xác nhận bằng </a:t>
+            </a:r>
+            <a:r>
+              <a:rPr lang="vi-VN" sz="1200" dirty="0" err="1">
+                <a:solidFill>
+                  <a:schemeClr val="bg1"/>
+                </a:solidFill>
+              </a:rPr>
+              <a:t>Null</a:t>
+            </a:r>
+            <a:r>
+              <a:rPr lang="vi-VN" sz="1200" dirty="0">
+                <a:solidFill>
+                  <a:schemeClr val="bg1"/>
+                </a:solidFill>
+              </a:rPr>
+              <a:t> </a:t>
+            </a:r>
+            <a:r>
+              <a:rPr lang="vi-VN" sz="1200" dirty="0" err="1">
+                <a:solidFill>
+                  <a:schemeClr val="bg1"/>
+                </a:solidFill>
+              </a:rPr>
+              <a:t>Simulation</a:t>
+            </a:r>
+            <a:endParaRPr lang="vi-VN" sz="1200" dirty="0">
+              <a:solidFill>
+                <a:schemeClr val="bg1"/>
+              </a:solidFill>
+            </a:endParaRPr>
+          </a:p>
+          <a:p>
+            <a:r>
+              <a:rPr lang="vi-VN" sz="1200" dirty="0">
+                <a:solidFill>
+                  <a:schemeClr val="bg1"/>
+                </a:solidFill>
+              </a:rPr>
+              <a:t>  </a:t>
+            </a:r>
+            <a:r>
+              <a:rPr lang="vi-VN" sz="1200" dirty="0" err="1">
+                <a:solidFill>
+                  <a:schemeClr val="bg1"/>
+                </a:solidFill>
+              </a:rPr>
+              <a:t>Gap</a:t>
+            </a:r>
+            <a:r>
+              <a:rPr lang="vi-VN" sz="1200" dirty="0">
+                <a:solidFill>
+                  <a:schemeClr val="bg1"/>
+                </a:solidFill>
+              </a:rPr>
+              <a:t> </a:t>
+            </a:r>
+            <a:r>
+              <a:rPr lang="vi-VN" sz="1200" dirty="0" err="1">
+                <a:solidFill>
+                  <a:schemeClr val="bg1"/>
+                </a:solidFill>
+              </a:rPr>
+              <a:t>Silhouette</a:t>
+            </a:r>
+            <a:r>
+              <a:rPr lang="vi-VN" sz="1200" dirty="0">
+                <a:solidFill>
+                  <a:schemeClr val="bg1"/>
+                </a:solidFill>
+              </a:rPr>
+              <a:t> tại K=5 = 0.10 (cao nhất K=2..7)</a:t>
+            </a:r>
+          </a:p>
+          <a:p>
+            <a:endParaRPr lang="vi-VN" sz="1200" dirty="0">
+              <a:solidFill>
+                <a:schemeClr val="bg1"/>
+              </a:solidFill>
+            </a:endParaRPr>
+          </a:p>
+          <a:p>
+            <a:r>
+              <a:rPr lang="vi-VN" sz="1200" dirty="0">
+                <a:solidFill>
+                  <a:schemeClr val="bg1"/>
+                </a:solidFill>
+              </a:rPr>
+              <a:t>• </a:t>
+            </a:r>
+            <a:r>
+              <a:rPr lang="vi-VN" sz="1200" dirty="0" err="1">
+                <a:solidFill>
+                  <a:schemeClr val="bg1"/>
+                </a:solidFill>
+              </a:rPr>
+              <a:t>Stratified</a:t>
+            </a:r>
+            <a:r>
+              <a:rPr lang="vi-VN" sz="1200" dirty="0">
+                <a:solidFill>
+                  <a:schemeClr val="bg1"/>
+                </a:solidFill>
+              </a:rPr>
+              <a:t> </a:t>
+            </a:r>
+            <a:r>
+              <a:rPr lang="vi-VN" sz="1200" dirty="0" err="1">
+                <a:solidFill>
+                  <a:schemeClr val="bg1"/>
+                </a:solidFill>
+              </a:rPr>
+              <a:t>Randomization</a:t>
+            </a:r>
+            <a:r>
+              <a:rPr lang="vi-VN" sz="1200" dirty="0">
+                <a:solidFill>
+                  <a:schemeClr val="bg1"/>
+                </a:solidFill>
+              </a:rPr>
+              <a:t> cân bằng:</a:t>
+            </a:r>
+          </a:p>
+          <a:p>
+            <a:r>
+              <a:rPr lang="vi-VN" sz="1200" dirty="0">
+                <a:solidFill>
+                  <a:schemeClr val="bg1"/>
+                </a:solidFill>
+              </a:rPr>
+              <a:t>  Loại khách, Khu vực sống, Ngày ngủ đông</a:t>
             </a:r>
           </a:p>
         </p:txBody>
@@ -8945,14 +9108,20 @@
               </a:defRPr>
             </a:pPr>
             <a:r>
-              <a:t>• Thí nghiệm thành công khi: P-value &lt; 0.05 VÀ Incremental Rides &gt; MDE VÀ Lợi nhuận Margin Dương.</a:t>
+              <a:t>• Thí nghiệm thành công khi: P-value &lt; 0.05 VÀ ROI &gt; 0. Kết quả: Suburban Card (+20.7%) và Suburban Cash (+24.7%) đều đạt ngưỡng.</a:t>
             </a:r>
           </a:p>
         </p:txBody>
       </p:sp>
       <p:pic>
         <p:nvPicPr>
-          <p:cNvPr id="19" name="Picture 18" descr="elbow.png"/>
+          <p:cNvPr id="21" name="Picture 20">
+            <a:extLst>
+              <a:ext uri="{FF2B5EF4-FFF2-40B4-BE49-F238E27FC236}">
+                <a16:creationId xmlns:a16="http://schemas.microsoft.com/office/drawing/2014/main" id="{9D4587AD-D05E-A3C6-687A-FA8091F1C27A}"/>
+              </a:ext>
+            </a:extLst>
+          </p:cNvPr>
           <p:cNvPicPr>
             <a:picLocks noChangeAspect="1"/>
           </p:cNvPicPr>
@@ -8966,8 +9135,8 @@
         </p:blipFill>
         <p:spPr>
           <a:xfrm>
-            <a:off x="4572000" y="2286000"/>
-            <a:ext cx="4206240" cy="3381680"/>
+            <a:off x="4526280" y="2182761"/>
+            <a:ext cx="4526280" cy="2982120"/>
           </a:xfrm>
           <a:prstGeom prst="rect">
             <a:avLst/>

</xml_diff>